<commit_message>
Perbaikan struktur proyek: hapus gui_predict.py, tambahkan app_browser.py, serta perbarui .gitignore dan requirements.txt.
</commit_message>
<xml_diff>
--- a/DeteksiBeras_YOLO.pptx
+++ b/DeteksiBeras_YOLO.pptx
@@ -5,7 +5,7 @@
     <p:sldMasterId id="2147483648" r:id="rId1"/>
   </p:sldMasterIdLst>
   <p:notesMasterIdLst>
-    <p:notesMasterId r:id="rId17"/>
+    <p:notesMasterId r:id="rId14"/>
   </p:notesMasterIdLst>
   <p:sldIdLst>
     <p:sldId id="256" r:id="rId2"/>
@@ -18,11 +18,8 @@
     <p:sldId id="263" r:id="rId9"/>
     <p:sldId id="264" r:id="rId10"/>
     <p:sldId id="265" r:id="rId11"/>
-    <p:sldId id="266" r:id="rId12"/>
-    <p:sldId id="267" r:id="rId13"/>
-    <p:sldId id="268" r:id="rId14"/>
-    <p:sldId id="269" r:id="rId15"/>
-    <p:sldId id="270" r:id="rId16"/>
+    <p:sldId id="267" r:id="rId12"/>
+    <p:sldId id="270" r:id="rId13"/>
   </p:sldIdLst>
   <p:sldSz cx="9144000" cy="5143500" type="screen16x9"/>
   <p:notesSz cx="5143500" cy="9144000"/>
@@ -587,258 +584,6 @@
 </p:notes>
 </file>
 
-<file path=ppt/notesSlides/notesSlide13.xml><?xml version="1.0" encoding="utf-8"?>
-<p:notes xmlns:a="http://schemas.openxmlformats.org/drawingml/2006/main" xmlns:r="http://schemas.openxmlformats.org/officeDocument/2006/relationships" xmlns:p="http://schemas.openxmlformats.org/presentationml/2006/main">
-  <p:cSld>
-    <p:spTree>
-      <p:nvGrpSpPr>
-        <p:cNvPr id="1" name=""/>
-        <p:cNvGrpSpPr/>
-        <p:nvPr/>
-      </p:nvGrpSpPr>
-      <p:grpSpPr>
-        <a:xfrm>
-          <a:off x="0" y="0"/>
-          <a:ext cx="0" cy="0"/>
-          <a:chOff x="0" y="0"/>
-          <a:chExt cx="0" cy="0"/>
-        </a:xfrm>
-      </p:grpSpPr>
-      <p:sp>
-        <p:nvSpPr>
-          <p:cNvPr id="2" name="Slide Image Placeholder 1"/>
-          <p:cNvSpPr>
-            <a:spLocks noGrp="1" noRot="1" noChangeAspect="1"/>
-          </p:cNvSpPr>
-          <p:nvPr>
-            <p:ph type="sldImg"/>
-          </p:nvPr>
-        </p:nvSpPr>
-        <p:spPr/>
-      </p:sp>
-      <p:sp>
-        <p:nvSpPr>
-          <p:cNvPr id="3" name="Notes Placeholder 2"/>
-          <p:cNvSpPr>
-            <a:spLocks noGrp="1"/>
-          </p:cNvSpPr>
-          <p:nvPr>
-            <p:ph type="body" idx="1"/>
-          </p:nvPr>
-        </p:nvSpPr>
-        <p:spPr/>
-        <p:txBody>
-          <a:bodyPr/>
-          <a:lstStyle/>
-          <a:p>
-            <a:endParaRPr lang="en-US" dirty="0"/>
-          </a:p>
-        </p:txBody>
-      </p:sp>
-      <p:sp>
-        <p:nvSpPr>
-          <p:cNvPr id="4" name="Slide Number Placeholder 3"/>
-          <p:cNvSpPr>
-            <a:spLocks noGrp="1"/>
-          </p:cNvSpPr>
-          <p:nvPr>
-            <p:ph type="sldNum" sz="quarter" idx="10"/>
-          </p:nvPr>
-        </p:nvSpPr>
-        <p:spPr/>
-        <p:txBody>
-          <a:bodyPr/>
-          <a:lstStyle/>
-          <a:p>
-            <a:fld id="{F7021451-1387-4CA6-816F-3879F97B5CBC}" type="slidenum">
-              <a:rPr lang="en-US"/>
-              <a:t>13</a:t>
-            </a:fld>
-            <a:endParaRPr lang="en-US"/>
-          </a:p>
-        </p:txBody>
-      </p:sp>
-    </p:spTree>
-    <p:extLst>
-      <p:ext uri="{BB962C8B-B14F-4D97-AF65-F5344CB8AC3E}">
-        <p14:creationId xmlns:p14="http://schemas.microsoft.com/office/powerpoint/2010/main" val="1024086991"/>
-      </p:ext>
-    </p:extLst>
-  </p:cSld>
-  <p:clrMapOvr>
-    <a:masterClrMapping/>
-  </p:clrMapOvr>
-</p:notes>
-</file>
-
-<file path=ppt/notesSlides/notesSlide14.xml><?xml version="1.0" encoding="utf-8"?>
-<p:notes xmlns:a="http://schemas.openxmlformats.org/drawingml/2006/main" xmlns:r="http://schemas.openxmlformats.org/officeDocument/2006/relationships" xmlns:p="http://schemas.openxmlformats.org/presentationml/2006/main">
-  <p:cSld>
-    <p:spTree>
-      <p:nvGrpSpPr>
-        <p:cNvPr id="1" name=""/>
-        <p:cNvGrpSpPr/>
-        <p:nvPr/>
-      </p:nvGrpSpPr>
-      <p:grpSpPr>
-        <a:xfrm>
-          <a:off x="0" y="0"/>
-          <a:ext cx="0" cy="0"/>
-          <a:chOff x="0" y="0"/>
-          <a:chExt cx="0" cy="0"/>
-        </a:xfrm>
-      </p:grpSpPr>
-      <p:sp>
-        <p:nvSpPr>
-          <p:cNvPr id="2" name="Slide Image Placeholder 1"/>
-          <p:cNvSpPr>
-            <a:spLocks noGrp="1" noRot="1" noChangeAspect="1"/>
-          </p:cNvSpPr>
-          <p:nvPr>
-            <p:ph type="sldImg"/>
-          </p:nvPr>
-        </p:nvSpPr>
-        <p:spPr/>
-      </p:sp>
-      <p:sp>
-        <p:nvSpPr>
-          <p:cNvPr id="3" name="Notes Placeholder 2"/>
-          <p:cNvSpPr>
-            <a:spLocks noGrp="1"/>
-          </p:cNvSpPr>
-          <p:nvPr>
-            <p:ph type="body" idx="1"/>
-          </p:nvPr>
-        </p:nvSpPr>
-        <p:spPr/>
-        <p:txBody>
-          <a:bodyPr/>
-          <a:lstStyle/>
-          <a:p>
-            <a:endParaRPr lang="en-US" dirty="0"/>
-          </a:p>
-        </p:txBody>
-      </p:sp>
-      <p:sp>
-        <p:nvSpPr>
-          <p:cNvPr id="4" name="Slide Number Placeholder 3"/>
-          <p:cNvSpPr>
-            <a:spLocks noGrp="1"/>
-          </p:cNvSpPr>
-          <p:nvPr>
-            <p:ph type="sldNum" sz="quarter" idx="10"/>
-          </p:nvPr>
-        </p:nvSpPr>
-        <p:spPr/>
-        <p:txBody>
-          <a:bodyPr/>
-          <a:lstStyle/>
-          <a:p>
-            <a:fld id="{F7021451-1387-4CA6-816F-3879F97B5CBC}" type="slidenum">
-              <a:rPr lang="en-US"/>
-              <a:t>14</a:t>
-            </a:fld>
-            <a:endParaRPr lang="en-US"/>
-          </a:p>
-        </p:txBody>
-      </p:sp>
-    </p:spTree>
-    <p:extLst>
-      <p:ext uri="{BB962C8B-B14F-4D97-AF65-F5344CB8AC3E}">
-        <p14:creationId xmlns:p14="http://schemas.microsoft.com/office/powerpoint/2010/main" val="1024086991"/>
-      </p:ext>
-    </p:extLst>
-  </p:cSld>
-  <p:clrMapOvr>
-    <a:masterClrMapping/>
-  </p:clrMapOvr>
-</p:notes>
-</file>
-
-<file path=ppt/notesSlides/notesSlide15.xml><?xml version="1.0" encoding="utf-8"?>
-<p:notes xmlns:a="http://schemas.openxmlformats.org/drawingml/2006/main" xmlns:r="http://schemas.openxmlformats.org/officeDocument/2006/relationships" xmlns:p="http://schemas.openxmlformats.org/presentationml/2006/main">
-  <p:cSld>
-    <p:spTree>
-      <p:nvGrpSpPr>
-        <p:cNvPr id="1" name=""/>
-        <p:cNvGrpSpPr/>
-        <p:nvPr/>
-      </p:nvGrpSpPr>
-      <p:grpSpPr>
-        <a:xfrm>
-          <a:off x="0" y="0"/>
-          <a:ext cx="0" cy="0"/>
-          <a:chOff x="0" y="0"/>
-          <a:chExt cx="0" cy="0"/>
-        </a:xfrm>
-      </p:grpSpPr>
-      <p:sp>
-        <p:nvSpPr>
-          <p:cNvPr id="2" name="Slide Image Placeholder 1"/>
-          <p:cNvSpPr>
-            <a:spLocks noGrp="1" noRot="1" noChangeAspect="1"/>
-          </p:cNvSpPr>
-          <p:nvPr>
-            <p:ph type="sldImg"/>
-          </p:nvPr>
-        </p:nvSpPr>
-        <p:spPr/>
-      </p:sp>
-      <p:sp>
-        <p:nvSpPr>
-          <p:cNvPr id="3" name="Notes Placeholder 2"/>
-          <p:cNvSpPr>
-            <a:spLocks noGrp="1"/>
-          </p:cNvSpPr>
-          <p:nvPr>
-            <p:ph type="body" idx="1"/>
-          </p:nvPr>
-        </p:nvSpPr>
-        <p:spPr/>
-        <p:txBody>
-          <a:bodyPr/>
-          <a:lstStyle/>
-          <a:p>
-            <a:endParaRPr lang="en-US" dirty="0"/>
-          </a:p>
-        </p:txBody>
-      </p:sp>
-      <p:sp>
-        <p:nvSpPr>
-          <p:cNvPr id="4" name="Slide Number Placeholder 3"/>
-          <p:cNvSpPr>
-            <a:spLocks noGrp="1"/>
-          </p:cNvSpPr>
-          <p:nvPr>
-            <p:ph type="sldNum" sz="quarter" idx="10"/>
-          </p:nvPr>
-        </p:nvSpPr>
-        <p:spPr/>
-        <p:txBody>
-          <a:bodyPr/>
-          <a:lstStyle/>
-          <a:p>
-            <a:fld id="{F7021451-1387-4CA6-816F-3879F97B5CBC}" type="slidenum">
-              <a:rPr lang="en-US"/>
-              <a:t>15</a:t>
-            </a:fld>
-            <a:endParaRPr lang="en-US"/>
-          </a:p>
-        </p:txBody>
-      </p:sp>
-    </p:spTree>
-    <p:extLst>
-      <p:ext uri="{BB962C8B-B14F-4D97-AF65-F5344CB8AC3E}">
-        <p14:creationId xmlns:p14="http://schemas.microsoft.com/office/powerpoint/2010/main" val="1024086991"/>
-      </p:ext>
-    </p:extLst>
-  </p:cSld>
-  <p:clrMapOvr>
-    <a:masterClrMapping/>
-  </p:clrMapOvr>
-</p:notes>
-</file>
-
 <file path=ppt/notesSlides/notesSlide2.xml><?xml version="1.0" encoding="utf-8"?>
 <p:notes xmlns:a="http://schemas.openxmlformats.org/drawingml/2006/main" xmlns:r="http://schemas.openxmlformats.org/officeDocument/2006/relationships" xmlns:p="http://schemas.openxmlformats.org/presentationml/2006/main">
   <p:cSld>
@@ -1944,7 +1689,7 @@
         <p:spPr>
           <a:xfrm>
             <a:off x="548640" y="502920"/>
-            <a:ext cx="2377440" cy="347472"/>
+            <a:ext cx="3747134" cy="347472"/>
           </a:xfrm>
           <a:prstGeom prst="roundRect">
             <a:avLst>
@@ -1970,8 +1715,8 @@
         </p:nvSpPr>
         <p:spPr>
           <a:xfrm>
-            <a:off x="548640" y="502920"/>
-            <a:ext cx="2377440" cy="347472"/>
+            <a:off x="548639" y="502920"/>
+            <a:ext cx="3747135" cy="347472"/>
           </a:xfrm>
           <a:prstGeom prst="rect">
             <a:avLst/>
@@ -1992,7 +1737,7 @@
                   <a:srgbClr val="0D3B2E"/>
                 </a:solidFill>
               </a:rPr>
-              <a:t>FINAL PROJECT</a:t>
+              <a:t>FINAL PROJECT – MACHINE LEARNING</a:t>
             </a:r>
             <a:endParaRPr lang="en-US" dirty="0"/>
           </a:p>
@@ -2087,18 +1832,7 @@
                 <a:ea typeface="Calibri" pitchFamily="34" charset="-122"/>
                 <a:cs typeface="Calibri" pitchFamily="34" charset="-120"/>
               </a:rPr>
-              <a:t>Berbasis Python  •  </a:t>
-            </a:r>
-            <a:r>
-              <a:rPr lang="en-US" sz="1600" dirty="0">
-                <a:solidFill>
-                  <a:srgbClr val="AACFBF"/>
-                </a:solidFill>
-                <a:latin typeface="Calibri" pitchFamily="34" charset="0"/>
-                <a:ea typeface="Calibri" pitchFamily="34" charset="-122"/>
-                <a:cs typeface="Calibri" pitchFamily="34" charset="-120"/>
-              </a:rPr>
-              <a:t>Deteksi Kelas Beras dari Gambar</a:t>
+              <a:t>Berbasis Python </a:t>
             </a:r>
             <a:endParaRPr lang="en-US" sz="1600" dirty="0"/>
           </a:p>
@@ -2112,7 +1846,7 @@
         </p:nvSpPr>
         <p:spPr>
           <a:xfrm>
-            <a:off x="5860169" y="3895344"/>
+            <a:off x="5619888" y="3895344"/>
             <a:ext cx="1601869" cy="804672"/>
           </a:xfrm>
           <a:prstGeom prst="rect">
@@ -2177,7 +1911,7 @@
               <a:buNone/>
             </a:pPr>
             <a:r>
-              <a:rPr lang="en-US" sz="1500" i="1" dirty="0" err="1">
+              <a:rPr lang="en-US" sz="1500" i="1" dirty="0">
                 <a:solidFill>
                   <a:srgbClr val="8ABFAA"/>
                 </a:solidFill>
@@ -2185,18 +1919,7 @@
                 <a:ea typeface="Calibri" pitchFamily="34" charset="-122"/>
                 <a:cs typeface="Calibri" pitchFamily="34" charset="-120"/>
               </a:rPr>
-              <a:t>Ramalah</a:t>
-            </a:r>
-            <a:r>
-              <a:rPr lang="en-US" sz="1500" i="1" dirty="0">
-                <a:solidFill>
-                  <a:srgbClr val="8ABFAA"/>
-                </a:solidFill>
-                <a:latin typeface="Calibri" pitchFamily="34" charset="0"/>
-                <a:ea typeface="Calibri" pitchFamily="34" charset="-122"/>
-                <a:cs typeface="Calibri" pitchFamily="34" charset="-120"/>
-              </a:rPr>
-              <a:t> Salam</a:t>
+              <a:t>Ramallah Salam</a:t>
             </a:r>
           </a:p>
         </p:txBody>
@@ -2244,7 +1967,7 @@
         </p:nvSpPr>
         <p:spPr>
           <a:xfrm>
-            <a:off x="7132320" y="3895344"/>
+            <a:off x="7176371" y="3895344"/>
             <a:ext cx="1601869" cy="804672"/>
           </a:xfrm>
           <a:prstGeom prst="rect">
@@ -2366,7 +2089,7 @@
         </p:nvSpPr>
         <p:spPr>
           <a:xfrm>
-            <a:off x="320040" y="137160"/>
+            <a:off x="320040" y="241935"/>
             <a:ext cx="457200" cy="457200"/>
           </a:xfrm>
           <a:prstGeom prst="roundRect">
@@ -2393,7 +2116,7 @@
         </p:nvSpPr>
         <p:spPr>
           <a:xfrm>
-            <a:off x="320040" y="137160"/>
+            <a:off x="320040" y="241935"/>
             <a:ext cx="457200" cy="457200"/>
           </a:xfrm>
           <a:prstGeom prst="rect">
@@ -3331,890 +3054,6 @@
 </file>
 
 <file path=ppt/slides/slide11.xml><?xml version="1.0" encoding="utf-8"?>
-<p:sld xmlns:a="http://schemas.openxmlformats.org/drawingml/2006/main" xmlns:r="http://schemas.openxmlformats.org/officeDocument/2006/relationships" xmlns:p="http://schemas.openxmlformats.org/presentationml/2006/main">
-  <p:cSld name="Slide 11">
-    <p:bg>
-      <p:bgPr>
-        <a:solidFill>
-          <a:srgbClr val="FFFFFF"/>
-        </a:solidFill>
-        <a:effectLst/>
-      </p:bgPr>
-    </p:bg>
-    <p:spTree>
-      <p:nvGrpSpPr>
-        <p:cNvPr id="1" name=""/>
-        <p:cNvGrpSpPr/>
-        <p:nvPr/>
-      </p:nvGrpSpPr>
-      <p:grpSpPr>
-        <a:xfrm>
-          <a:off x="0" y="0"/>
-          <a:ext cx="0" cy="0"/>
-          <a:chOff x="0" y="0"/>
-          <a:chExt cx="0" cy="0"/>
-        </a:xfrm>
-      </p:grpSpPr>
-      <p:sp>
-        <p:nvSpPr>
-          <p:cNvPr id="2" name="Shape 0"/>
-          <p:cNvSpPr/>
-          <p:nvPr/>
-        </p:nvSpPr>
-        <p:spPr>
-          <a:xfrm>
-            <a:off x="0" y="0"/>
-            <a:ext cx="9144000" cy="914400"/>
-          </a:xfrm>
-          <a:prstGeom prst="rect">
-            <a:avLst/>
-          </a:prstGeom>
-          <a:solidFill>
-            <a:srgbClr val="0D3B2E"/>
-          </a:solidFill>
-          <a:ln w="12700">
-            <a:solidFill>
-              <a:srgbClr val="0D3B2E"/>
-            </a:solidFill>
-            <a:prstDash val="solid"/>
-          </a:ln>
-        </p:spPr>
-      </p:sp>
-      <p:sp>
-        <p:nvSpPr>
-          <p:cNvPr id="3" name="Shape 1"/>
-          <p:cNvSpPr/>
-          <p:nvPr/>
-        </p:nvSpPr>
-        <p:spPr>
-          <a:xfrm>
-            <a:off x="320040" y="137160"/>
-            <a:ext cx="457200" cy="457200"/>
-          </a:xfrm>
-          <a:prstGeom prst="roundRect">
-            <a:avLst>
-              <a:gd name="adj" fmla="val 12000"/>
-            </a:avLst>
-          </a:prstGeom>
-          <a:solidFill>
-            <a:srgbClr val="2ECC8F"/>
-          </a:solidFill>
-          <a:ln w="12700">
-            <a:solidFill>
-              <a:srgbClr val="2ECC8F"/>
-            </a:solidFill>
-            <a:prstDash val="solid"/>
-          </a:ln>
-        </p:spPr>
-      </p:sp>
-      <p:sp>
-        <p:nvSpPr>
-          <p:cNvPr id="4" name="Text 2"/>
-          <p:cNvSpPr/>
-          <p:nvPr/>
-        </p:nvSpPr>
-        <p:spPr>
-          <a:xfrm>
-            <a:off x="320040" y="137160"/>
-            <a:ext cx="457200" cy="457200"/>
-          </a:xfrm>
-          <a:prstGeom prst="rect">
-            <a:avLst/>
-          </a:prstGeom>
-          <a:noFill/>
-          <a:ln/>
-        </p:spPr>
-        <p:txBody>
-          <a:bodyPr wrap="square" lIns="0" tIns="0" rIns="0" bIns="0" rtlCol="0" anchor="ctr"/>
-          <a:lstStyle/>
-          <a:p>
-            <a:pPr marL="0" indent="0" algn="ctr">
-              <a:buNone/>
-            </a:pPr>
-            <a:r>
-              <a:rPr lang="en-US" sz="1300" b="1" dirty="0">
-                <a:solidFill>
-                  <a:srgbClr val="0D3B2E"/>
-                </a:solidFill>
-              </a:rPr>
-              <a:t>11</a:t>
-            </a:r>
-            <a:endParaRPr lang="en-US" sz="1300" dirty="0"/>
-          </a:p>
-        </p:txBody>
-      </p:sp>
-      <p:sp>
-        <p:nvSpPr>
-          <p:cNvPr id="5" name="Text 3"/>
-          <p:cNvSpPr/>
-          <p:nvPr/>
-        </p:nvSpPr>
-        <p:spPr>
-          <a:xfrm>
-            <a:off x="914400" y="109728"/>
-            <a:ext cx="7955280" cy="694944"/>
-          </a:xfrm>
-          <a:prstGeom prst="rect">
-            <a:avLst/>
-          </a:prstGeom>
-          <a:noFill/>
-          <a:ln/>
-        </p:spPr>
-        <p:txBody>
-          <a:bodyPr wrap="square" rtlCol="0" anchor="ctr"/>
-          <a:lstStyle/>
-          <a:p>
-            <a:pPr marL="0" indent="0">
-              <a:buNone/>
-            </a:pPr>
-            <a:r>
-              <a:rPr lang="en-US" sz="2200" b="1" dirty="0">
-                <a:solidFill>
-                  <a:srgbClr val="FFFFFF"/>
-                </a:solidFill>
-                <a:latin typeface="Cambria" pitchFamily="34" charset="0"/>
-                <a:ea typeface="Cambria" pitchFamily="34" charset="-122"/>
-                <a:cs typeface="Cambria" pitchFamily="34" charset="-120"/>
-              </a:rPr>
-              <a:t>Penjelasan run.py</a:t>
-            </a:r>
-            <a:endParaRPr lang="en-US" sz="2200" dirty="0"/>
-          </a:p>
-        </p:txBody>
-      </p:sp>
-      <p:sp>
-        <p:nvSpPr>
-          <p:cNvPr id="6" name="Shape 4"/>
-          <p:cNvSpPr/>
-          <p:nvPr/>
-        </p:nvSpPr>
-        <p:spPr>
-          <a:xfrm>
-            <a:off x="7863840" y="-274320"/>
-            <a:ext cx="1463040" cy="1463040"/>
-          </a:xfrm>
-          <a:prstGeom prst="ellipse">
-            <a:avLst/>
-          </a:prstGeom>
-          <a:solidFill>
-            <a:srgbClr val="2ECC8F">
-              <a:alpha val="20000"/>
-            </a:srgbClr>
-          </a:solidFill>
-          <a:ln w="12700">
-            <a:solidFill>
-              <a:srgbClr val="2ECC8F">
-                <a:alpha val="20000"/>
-              </a:srgbClr>
-            </a:solidFill>
-            <a:prstDash val="solid"/>
-          </a:ln>
-        </p:spPr>
-      </p:sp>
-      <p:sp>
-        <p:nvSpPr>
-          <p:cNvPr id="7" name="Shape 5"/>
-          <p:cNvSpPr/>
-          <p:nvPr/>
-        </p:nvSpPr>
-        <p:spPr>
-          <a:xfrm>
-            <a:off x="411480" y="1051560"/>
-            <a:ext cx="8321040" cy="658368"/>
-          </a:xfrm>
-          <a:prstGeom prst="roundRect">
-            <a:avLst>
-              <a:gd name="adj" fmla="val 11111"/>
-            </a:avLst>
-          </a:prstGeom>
-          <a:solidFill>
-            <a:srgbClr val="F4FAF7"/>
-          </a:solidFill>
-          <a:ln w="6350">
-            <a:solidFill>
-              <a:srgbClr val="D0E8DC"/>
-            </a:solidFill>
-            <a:prstDash val="solid"/>
-          </a:ln>
-          <a:effectLst>
-            <a:outerShdw blurRad="101600" dist="38100" dir="2700000" algn="bl" rotWithShape="0">
-              <a:srgbClr val="000000">
-                <a:alpha val="12000"/>
-              </a:srgbClr>
-            </a:outerShdw>
-          </a:effectLst>
-        </p:spPr>
-      </p:sp>
-      <p:sp>
-        <p:nvSpPr>
-          <p:cNvPr id="8" name="Shape 6"/>
-          <p:cNvSpPr/>
-          <p:nvPr/>
-        </p:nvSpPr>
-        <p:spPr>
-          <a:xfrm>
-            <a:off x="548640" y="1161288"/>
-            <a:ext cx="3017520" cy="420624"/>
-          </a:xfrm>
-          <a:prstGeom prst="roundRect">
-            <a:avLst>
-              <a:gd name="adj" fmla="val 13043"/>
-            </a:avLst>
-          </a:prstGeom>
-          <a:solidFill>
-            <a:srgbClr val="1A6B4A"/>
-          </a:solidFill>
-          <a:ln w="12700">
-            <a:solidFill>
-              <a:srgbClr val="1A6B4A"/>
-            </a:solidFill>
-            <a:prstDash val="solid"/>
-          </a:ln>
-        </p:spPr>
-      </p:sp>
-      <p:sp>
-        <p:nvSpPr>
-          <p:cNvPr id="9" name="Text 7"/>
-          <p:cNvSpPr/>
-          <p:nvPr/>
-        </p:nvSpPr>
-        <p:spPr>
-          <a:xfrm>
-            <a:off x="548640" y="1161288"/>
-            <a:ext cx="3017520" cy="420624"/>
-          </a:xfrm>
-          <a:prstGeom prst="rect">
-            <a:avLst/>
-          </a:prstGeom>
-          <a:noFill/>
-          <a:ln/>
-        </p:spPr>
-        <p:txBody>
-          <a:bodyPr wrap="square" lIns="0" tIns="0" rIns="0" bIns="0" rtlCol="0" anchor="ctr"/>
-          <a:lstStyle/>
-          <a:p>
-            <a:pPr marL="0" indent="0" algn="ctr">
-              <a:buNone/>
-            </a:pPr>
-            <a:r>
-              <a:rPr lang="en-US" sz="1250" b="1" dirty="0">
-                <a:solidFill>
-                  <a:srgbClr val="FFFFFF"/>
-                </a:solidFill>
-                <a:latin typeface="Courier New" pitchFamily="34" charset="0"/>
-                <a:ea typeface="Courier New" pitchFamily="34" charset="-122"/>
-                <a:cs typeface="Courier New" pitchFamily="34" charset="-120"/>
-              </a:rPr>
-              <a:t>prepare_dataset()</a:t>
-            </a:r>
-            <a:endParaRPr lang="en-US" sz="1250" dirty="0"/>
-          </a:p>
-        </p:txBody>
-      </p:sp>
-      <p:sp>
-        <p:nvSpPr>
-          <p:cNvPr id="10" name="Text 8"/>
-          <p:cNvSpPr/>
-          <p:nvPr/>
-        </p:nvSpPr>
-        <p:spPr>
-          <a:xfrm>
-            <a:off x="3749040" y="1051560"/>
-            <a:ext cx="4663440" cy="658368"/>
-          </a:xfrm>
-          <a:prstGeom prst="rect">
-            <a:avLst/>
-          </a:prstGeom>
-          <a:noFill/>
-          <a:ln/>
-        </p:spPr>
-        <p:txBody>
-          <a:bodyPr wrap="square" rtlCol="0" anchor="ctr"/>
-          <a:lstStyle/>
-          <a:p>
-            <a:pPr marL="0" indent="0">
-              <a:buNone/>
-            </a:pPr>
-            <a:r>
-              <a:rPr lang="en-US" sz="1300" dirty="0">
-                <a:solidFill>
-                  <a:srgbClr val="1E2D27"/>
-                </a:solidFill>
-                <a:latin typeface="Calibri" pitchFamily="34" charset="0"/>
-                <a:ea typeface="Calibri" pitchFamily="34" charset="-122"/>
-                <a:cs typeface="Calibri" pitchFamily="34" charset="-120"/>
-              </a:rPr>
-              <a:t>Membuat dan mengonversi dataset ke format YOLO</a:t>
-            </a:r>
-            <a:endParaRPr lang="en-US" sz="1300" dirty="0"/>
-          </a:p>
-        </p:txBody>
-      </p:sp>
-      <p:sp>
-        <p:nvSpPr>
-          <p:cNvPr id="11" name="Shape 9"/>
-          <p:cNvSpPr/>
-          <p:nvPr/>
-        </p:nvSpPr>
-        <p:spPr>
-          <a:xfrm>
-            <a:off x="411480" y="1837944"/>
-            <a:ext cx="8321040" cy="658368"/>
-          </a:xfrm>
-          <a:prstGeom prst="roundRect">
-            <a:avLst>
-              <a:gd name="adj" fmla="val 11111"/>
-            </a:avLst>
-          </a:prstGeom>
-          <a:solidFill>
-            <a:srgbClr val="E8F5F0"/>
-          </a:solidFill>
-          <a:ln w="6350">
-            <a:solidFill>
-              <a:srgbClr val="D0E8DC"/>
-            </a:solidFill>
-            <a:prstDash val="solid"/>
-          </a:ln>
-          <a:effectLst>
-            <a:outerShdw blurRad="101600" dist="38100" dir="2700000" algn="bl" rotWithShape="0">
-              <a:srgbClr val="000000">
-                <a:alpha val="12000"/>
-              </a:srgbClr>
-            </a:outerShdw>
-          </a:effectLst>
-        </p:spPr>
-      </p:sp>
-      <p:sp>
-        <p:nvSpPr>
-          <p:cNvPr id="12" name="Shape 10"/>
-          <p:cNvSpPr/>
-          <p:nvPr/>
-        </p:nvSpPr>
-        <p:spPr>
-          <a:xfrm>
-            <a:off x="548640" y="1947672"/>
-            <a:ext cx="3017520" cy="420624"/>
-          </a:xfrm>
-          <a:prstGeom prst="roundRect">
-            <a:avLst>
-              <a:gd name="adj" fmla="val 13043"/>
-            </a:avLst>
-          </a:prstGeom>
-          <a:solidFill>
-            <a:srgbClr val="1A6B4A"/>
-          </a:solidFill>
-          <a:ln w="12700">
-            <a:solidFill>
-              <a:srgbClr val="1A6B4A"/>
-            </a:solidFill>
-            <a:prstDash val="solid"/>
-          </a:ln>
-        </p:spPr>
-      </p:sp>
-      <p:sp>
-        <p:nvSpPr>
-          <p:cNvPr id="13" name="Text 11"/>
-          <p:cNvSpPr/>
-          <p:nvPr/>
-        </p:nvSpPr>
-        <p:spPr>
-          <a:xfrm>
-            <a:off x="548640" y="1947672"/>
-            <a:ext cx="3017520" cy="420624"/>
-          </a:xfrm>
-          <a:prstGeom prst="rect">
-            <a:avLst/>
-          </a:prstGeom>
-          <a:noFill/>
-          <a:ln/>
-        </p:spPr>
-        <p:txBody>
-          <a:bodyPr wrap="square" lIns="0" tIns="0" rIns="0" bIns="0" rtlCol="0" anchor="ctr"/>
-          <a:lstStyle/>
-          <a:p>
-            <a:pPr marL="0" indent="0" algn="ctr">
-              <a:buNone/>
-            </a:pPr>
-            <a:r>
-              <a:rPr lang="en-US" sz="1250" b="1" dirty="0">
-                <a:solidFill>
-                  <a:srgbClr val="FFFFFF"/>
-                </a:solidFill>
-                <a:latin typeface="Courier New" pitchFamily="34" charset="0"/>
-                <a:ea typeface="Courier New" pitchFamily="34" charset="-122"/>
-                <a:cs typeface="Courier New" pitchFamily="34" charset="-120"/>
-              </a:rPr>
-              <a:t>train_model()</a:t>
-            </a:r>
-            <a:endParaRPr lang="en-US" sz="1250" dirty="0"/>
-          </a:p>
-        </p:txBody>
-      </p:sp>
-      <p:sp>
-        <p:nvSpPr>
-          <p:cNvPr id="14" name="Text 12"/>
-          <p:cNvSpPr/>
-          <p:nvPr/>
-        </p:nvSpPr>
-        <p:spPr>
-          <a:xfrm>
-            <a:off x="3749040" y="1837944"/>
-            <a:ext cx="4663440" cy="658368"/>
-          </a:xfrm>
-          <a:prstGeom prst="rect">
-            <a:avLst/>
-          </a:prstGeom>
-          <a:noFill/>
-          <a:ln/>
-        </p:spPr>
-        <p:txBody>
-          <a:bodyPr wrap="square" rtlCol="0" anchor="ctr"/>
-          <a:lstStyle/>
-          <a:p>
-            <a:pPr marL="0" indent="0">
-              <a:buNone/>
-            </a:pPr>
-            <a:r>
-              <a:rPr lang="en-US" sz="1300" dirty="0">
-                <a:solidFill>
-                  <a:srgbClr val="1E2D27"/>
-                </a:solidFill>
-                <a:latin typeface="Calibri" pitchFamily="34" charset="0"/>
-                <a:ea typeface="Calibri" pitchFamily="34" charset="-122"/>
-                <a:cs typeface="Calibri" pitchFamily="34" charset="-120"/>
-              </a:rPr>
-              <a:t>Melatih model YOLOv8 dengan dataset yang telah disiapkan</a:t>
-            </a:r>
-            <a:endParaRPr lang="en-US" sz="1300" dirty="0"/>
-          </a:p>
-        </p:txBody>
-      </p:sp>
-      <p:sp>
-        <p:nvSpPr>
-          <p:cNvPr id="15" name="Shape 13"/>
-          <p:cNvSpPr/>
-          <p:nvPr/>
-        </p:nvSpPr>
-        <p:spPr>
-          <a:xfrm>
-            <a:off x="411480" y="2624328"/>
-            <a:ext cx="8321040" cy="658368"/>
-          </a:xfrm>
-          <a:prstGeom prst="roundRect">
-            <a:avLst>
-              <a:gd name="adj" fmla="val 11111"/>
-            </a:avLst>
-          </a:prstGeom>
-          <a:solidFill>
-            <a:srgbClr val="F4FAF7"/>
-          </a:solidFill>
-          <a:ln w="6350">
-            <a:solidFill>
-              <a:srgbClr val="D0E8DC"/>
-            </a:solidFill>
-            <a:prstDash val="solid"/>
-          </a:ln>
-          <a:effectLst>
-            <a:outerShdw blurRad="101600" dist="38100" dir="2700000" algn="bl" rotWithShape="0">
-              <a:srgbClr val="000000">
-                <a:alpha val="12000"/>
-              </a:srgbClr>
-            </a:outerShdw>
-          </a:effectLst>
-        </p:spPr>
-      </p:sp>
-      <p:sp>
-        <p:nvSpPr>
-          <p:cNvPr id="16" name="Shape 14"/>
-          <p:cNvSpPr/>
-          <p:nvPr/>
-        </p:nvSpPr>
-        <p:spPr>
-          <a:xfrm>
-            <a:off x="548640" y="2734056"/>
-            <a:ext cx="3017520" cy="420624"/>
-          </a:xfrm>
-          <a:prstGeom prst="roundRect">
-            <a:avLst>
-              <a:gd name="adj" fmla="val 13043"/>
-            </a:avLst>
-          </a:prstGeom>
-          <a:solidFill>
-            <a:srgbClr val="1A6B4A"/>
-          </a:solidFill>
-          <a:ln w="12700">
-            <a:solidFill>
-              <a:srgbClr val="1A6B4A"/>
-            </a:solidFill>
-            <a:prstDash val="solid"/>
-          </a:ln>
-        </p:spPr>
-      </p:sp>
-      <p:sp>
-        <p:nvSpPr>
-          <p:cNvPr id="17" name="Text 15"/>
-          <p:cNvSpPr/>
-          <p:nvPr/>
-        </p:nvSpPr>
-        <p:spPr>
-          <a:xfrm>
-            <a:off x="548640" y="2734056"/>
-            <a:ext cx="3017520" cy="420624"/>
-          </a:xfrm>
-          <a:prstGeom prst="rect">
-            <a:avLst/>
-          </a:prstGeom>
-          <a:noFill/>
-          <a:ln/>
-        </p:spPr>
-        <p:txBody>
-          <a:bodyPr wrap="square" lIns="0" tIns="0" rIns="0" bIns="0" rtlCol="0" anchor="ctr"/>
-          <a:lstStyle/>
-          <a:p>
-            <a:pPr marL="0" indent="0" algn="ctr">
-              <a:buNone/>
-            </a:pPr>
-            <a:r>
-              <a:rPr lang="en-US" sz="1250" b="1" dirty="0">
-                <a:solidFill>
-                  <a:srgbClr val="FFFFFF"/>
-                </a:solidFill>
-                <a:latin typeface="Courier New" pitchFamily="34" charset="0"/>
-                <a:ea typeface="Courier New" pitchFamily="34" charset="-122"/>
-                <a:cs typeface="Courier New" pitchFamily="34" charset="-120"/>
-              </a:rPr>
-              <a:t>evaluate_model()</a:t>
-            </a:r>
-            <a:endParaRPr lang="en-US" sz="1250" dirty="0"/>
-          </a:p>
-        </p:txBody>
-      </p:sp>
-      <p:sp>
-        <p:nvSpPr>
-          <p:cNvPr id="18" name="Text 16"/>
-          <p:cNvSpPr/>
-          <p:nvPr/>
-        </p:nvSpPr>
-        <p:spPr>
-          <a:xfrm>
-            <a:off x="3749040" y="2624328"/>
-            <a:ext cx="4663440" cy="658368"/>
-          </a:xfrm>
-          <a:prstGeom prst="rect">
-            <a:avLst/>
-          </a:prstGeom>
-          <a:noFill/>
-          <a:ln/>
-        </p:spPr>
-        <p:txBody>
-          <a:bodyPr wrap="square" rtlCol="0" anchor="ctr"/>
-          <a:lstStyle/>
-          <a:p>
-            <a:pPr marL="0" indent="0">
-              <a:buNone/>
-            </a:pPr>
-            <a:r>
-              <a:rPr lang="en-US" sz="1300" dirty="0">
-                <a:solidFill>
-                  <a:srgbClr val="1E2D27"/>
-                </a:solidFill>
-                <a:latin typeface="Calibri" pitchFamily="34" charset="0"/>
-                <a:ea typeface="Calibri" pitchFamily="34" charset="-122"/>
-                <a:cs typeface="Calibri" pitchFamily="34" charset="-120"/>
-              </a:rPr>
-              <a:t>Mengukur performa model dengan metrik Precision, Recall, mAP</a:t>
-            </a:r>
-            <a:endParaRPr lang="en-US" sz="1300" dirty="0"/>
-          </a:p>
-        </p:txBody>
-      </p:sp>
-      <p:sp>
-        <p:nvSpPr>
-          <p:cNvPr id="19" name="Shape 17"/>
-          <p:cNvSpPr/>
-          <p:nvPr/>
-        </p:nvSpPr>
-        <p:spPr>
-          <a:xfrm>
-            <a:off x="411480" y="3410712"/>
-            <a:ext cx="8321040" cy="658368"/>
-          </a:xfrm>
-          <a:prstGeom prst="roundRect">
-            <a:avLst>
-              <a:gd name="adj" fmla="val 11111"/>
-            </a:avLst>
-          </a:prstGeom>
-          <a:solidFill>
-            <a:srgbClr val="E8F5F0"/>
-          </a:solidFill>
-          <a:ln w="6350">
-            <a:solidFill>
-              <a:srgbClr val="D0E8DC"/>
-            </a:solidFill>
-            <a:prstDash val="solid"/>
-          </a:ln>
-          <a:effectLst>
-            <a:outerShdw blurRad="101600" dist="38100" dir="2700000" algn="bl" rotWithShape="0">
-              <a:srgbClr val="000000">
-                <a:alpha val="12000"/>
-              </a:srgbClr>
-            </a:outerShdw>
-          </a:effectLst>
-        </p:spPr>
-      </p:sp>
-      <p:sp>
-        <p:nvSpPr>
-          <p:cNvPr id="20" name="Shape 18"/>
-          <p:cNvSpPr/>
-          <p:nvPr/>
-        </p:nvSpPr>
-        <p:spPr>
-          <a:xfrm>
-            <a:off x="548640" y="3520440"/>
-            <a:ext cx="3017520" cy="420624"/>
-          </a:xfrm>
-          <a:prstGeom prst="roundRect">
-            <a:avLst>
-              <a:gd name="adj" fmla="val 13043"/>
-            </a:avLst>
-          </a:prstGeom>
-          <a:solidFill>
-            <a:srgbClr val="1A6B4A"/>
-          </a:solidFill>
-          <a:ln w="12700">
-            <a:solidFill>
-              <a:srgbClr val="1A6B4A"/>
-            </a:solidFill>
-            <a:prstDash val="solid"/>
-          </a:ln>
-        </p:spPr>
-      </p:sp>
-      <p:sp>
-        <p:nvSpPr>
-          <p:cNvPr id="21" name="Text 19"/>
-          <p:cNvSpPr/>
-          <p:nvPr/>
-        </p:nvSpPr>
-        <p:spPr>
-          <a:xfrm>
-            <a:off x="548640" y="3520440"/>
-            <a:ext cx="3017520" cy="420624"/>
-          </a:xfrm>
-          <a:prstGeom prst="rect">
-            <a:avLst/>
-          </a:prstGeom>
-          <a:noFill/>
-          <a:ln/>
-        </p:spPr>
-        <p:txBody>
-          <a:bodyPr wrap="square" lIns="0" tIns="0" rIns="0" bIns="0" rtlCol="0" anchor="ctr"/>
-          <a:lstStyle/>
-          <a:p>
-            <a:pPr marL="0" indent="0" algn="ctr">
-              <a:buNone/>
-            </a:pPr>
-            <a:r>
-              <a:rPr lang="en-US" sz="1250" b="1" dirty="0">
-                <a:solidFill>
-                  <a:srgbClr val="FFFFFF"/>
-                </a:solidFill>
-                <a:latin typeface="Courier New" pitchFamily="34" charset="0"/>
-                <a:ea typeface="Courier New" pitchFamily="34" charset="-122"/>
-                <a:cs typeface="Courier New" pitchFamily="34" charset="-120"/>
-              </a:rPr>
-              <a:t>predict()</a:t>
-            </a:r>
-            <a:endParaRPr lang="en-US" sz="1250" dirty="0"/>
-          </a:p>
-        </p:txBody>
-      </p:sp>
-      <p:sp>
-        <p:nvSpPr>
-          <p:cNvPr id="22" name="Text 20"/>
-          <p:cNvSpPr/>
-          <p:nvPr/>
-        </p:nvSpPr>
-        <p:spPr>
-          <a:xfrm>
-            <a:off x="3749040" y="3410712"/>
-            <a:ext cx="4663440" cy="658368"/>
-          </a:xfrm>
-          <a:prstGeom prst="rect">
-            <a:avLst/>
-          </a:prstGeom>
-          <a:noFill/>
-          <a:ln/>
-        </p:spPr>
-        <p:txBody>
-          <a:bodyPr wrap="square" rtlCol="0" anchor="ctr"/>
-          <a:lstStyle/>
-          <a:p>
-            <a:pPr marL="0" indent="0">
-              <a:buNone/>
-            </a:pPr>
-            <a:r>
-              <a:rPr lang="en-US" sz="1300" dirty="0">
-                <a:solidFill>
-                  <a:srgbClr val="1E2D27"/>
-                </a:solidFill>
-                <a:latin typeface="Calibri" pitchFamily="34" charset="0"/>
-                <a:ea typeface="Calibri" pitchFamily="34" charset="-122"/>
-                <a:cs typeface="Calibri" pitchFamily="34" charset="-120"/>
-              </a:rPr>
-              <a:t>Prediksi gambar atau folder via command line</a:t>
-            </a:r>
-            <a:endParaRPr lang="en-US" sz="1300" dirty="0"/>
-          </a:p>
-        </p:txBody>
-      </p:sp>
-      <p:sp>
-        <p:nvSpPr>
-          <p:cNvPr id="23" name="Shape 21"/>
-          <p:cNvSpPr/>
-          <p:nvPr/>
-        </p:nvSpPr>
-        <p:spPr>
-          <a:xfrm>
-            <a:off x="411480" y="4197096"/>
-            <a:ext cx="8321040" cy="658368"/>
-          </a:xfrm>
-          <a:prstGeom prst="roundRect">
-            <a:avLst>
-              <a:gd name="adj" fmla="val 11111"/>
-            </a:avLst>
-          </a:prstGeom>
-          <a:solidFill>
-            <a:srgbClr val="F4FAF7"/>
-          </a:solidFill>
-          <a:ln w="6350">
-            <a:solidFill>
-              <a:srgbClr val="D0E8DC"/>
-            </a:solidFill>
-            <a:prstDash val="solid"/>
-          </a:ln>
-          <a:effectLst>
-            <a:outerShdw blurRad="101600" dist="38100" dir="2700000" algn="bl" rotWithShape="0">
-              <a:srgbClr val="000000">
-                <a:alpha val="12000"/>
-              </a:srgbClr>
-            </a:outerShdw>
-          </a:effectLst>
-        </p:spPr>
-      </p:sp>
-      <p:sp>
-        <p:nvSpPr>
-          <p:cNvPr id="24" name="Shape 22"/>
-          <p:cNvSpPr/>
-          <p:nvPr/>
-        </p:nvSpPr>
-        <p:spPr>
-          <a:xfrm>
-            <a:off x="548640" y="4306824"/>
-            <a:ext cx="3017520" cy="420624"/>
-          </a:xfrm>
-          <a:prstGeom prst="roundRect">
-            <a:avLst>
-              <a:gd name="adj" fmla="val 13043"/>
-            </a:avLst>
-          </a:prstGeom>
-          <a:solidFill>
-            <a:srgbClr val="1A6B4A"/>
-          </a:solidFill>
-          <a:ln w="12700">
-            <a:solidFill>
-              <a:srgbClr val="1A6B4A"/>
-            </a:solidFill>
-            <a:prstDash val="solid"/>
-          </a:ln>
-        </p:spPr>
-      </p:sp>
-      <p:sp>
-        <p:nvSpPr>
-          <p:cNvPr id="25" name="Text 23"/>
-          <p:cNvSpPr/>
-          <p:nvPr/>
-        </p:nvSpPr>
-        <p:spPr>
-          <a:xfrm>
-            <a:off x="548640" y="4306824"/>
-            <a:ext cx="3017520" cy="420624"/>
-          </a:xfrm>
-          <a:prstGeom prst="rect">
-            <a:avLst/>
-          </a:prstGeom>
-          <a:noFill/>
-          <a:ln/>
-        </p:spPr>
-        <p:txBody>
-          <a:bodyPr wrap="square" lIns="0" tIns="0" rIns="0" bIns="0" rtlCol="0" anchor="ctr"/>
-          <a:lstStyle/>
-          <a:p>
-            <a:pPr marL="0" indent="0" algn="ctr">
-              <a:buNone/>
-            </a:pPr>
-            <a:r>
-              <a:rPr lang="en-US" sz="1250" b="1" dirty="0">
-                <a:solidFill>
-                  <a:srgbClr val="FFFFFF"/>
-                </a:solidFill>
-                <a:latin typeface="Courier New" pitchFamily="34" charset="0"/>
-                <a:ea typeface="Courier New" pitchFamily="34" charset="-122"/>
-                <a:cs typeface="Courier New" pitchFamily="34" charset="-120"/>
-              </a:rPr>
-              <a:t>write_report()</a:t>
-            </a:r>
-            <a:endParaRPr lang="en-US" sz="1250" dirty="0"/>
-          </a:p>
-        </p:txBody>
-      </p:sp>
-      <p:sp>
-        <p:nvSpPr>
-          <p:cNvPr id="26" name="Text 24"/>
-          <p:cNvSpPr/>
-          <p:nvPr/>
-        </p:nvSpPr>
-        <p:spPr>
-          <a:xfrm>
-            <a:off x="3749040" y="4197096"/>
-            <a:ext cx="4663440" cy="658368"/>
-          </a:xfrm>
-          <a:prstGeom prst="rect">
-            <a:avLst/>
-          </a:prstGeom>
-          <a:noFill/>
-          <a:ln/>
-        </p:spPr>
-        <p:txBody>
-          <a:bodyPr wrap="square" rtlCol="0" anchor="ctr"/>
-          <a:lstStyle/>
-          <a:p>
-            <a:pPr marL="0" indent="0">
-              <a:buNone/>
-            </a:pPr>
-            <a:r>
-              <a:rPr lang="en-US" sz="1300" dirty="0">
-                <a:solidFill>
-                  <a:srgbClr val="1E2D27"/>
-                </a:solidFill>
-                <a:latin typeface="Calibri" pitchFamily="34" charset="0"/>
-                <a:ea typeface="Calibri" pitchFamily="34" charset="-122"/>
-                <a:cs typeface="Calibri" pitchFamily="34" charset="-120"/>
-              </a:rPr>
-              <a:t>Membuat laporan akhir hasil training dan evaluasi</a:t>
-            </a:r>
-            <a:endParaRPr lang="en-US" sz="1300" dirty="0"/>
-          </a:p>
-        </p:txBody>
-      </p:sp>
-    </p:spTree>
-  </p:cSld>
-  <p:clrMapOvr>
-    <a:masterClrMapping/>
-  </p:clrMapOvr>
-</p:sld>
-</file>
-
-<file path=ppt/slides/slide12.xml><?xml version="1.0" encoding="utf-8"?>
 <p:sld xmlns:a="http://schemas.openxmlformats.org/drawingml/2006/main" xmlns:r="http://schemas.openxmlformats.org/officeDocument/2006/relationships" xmlns:p="http://schemas.openxmlformats.org/presentationml/2006/main">
   <p:cSld name="Slide 12">
     <p:bg>
@@ -4272,7 +3111,7 @@
         </p:nvSpPr>
         <p:spPr>
           <a:xfrm>
-            <a:off x="320040" y="137160"/>
+            <a:off x="320040" y="232410"/>
             <a:ext cx="457200" cy="457200"/>
           </a:xfrm>
           <a:prstGeom prst="roundRect">
@@ -4299,7 +3138,7 @@
         </p:nvSpPr>
         <p:spPr>
           <a:xfrm>
-            <a:off x="320040" y="137160"/>
+            <a:off x="320040" y="232410"/>
             <a:ext cx="457200" cy="457200"/>
           </a:xfrm>
           <a:prstGeom prst="rect">
@@ -4321,7 +3160,7 @@
                   <a:srgbClr val="0D3B2E"/>
                 </a:solidFill>
               </a:rPr>
-              <a:t>12</a:t>
+              <a:t>11</a:t>
             </a:r>
             <a:endParaRPr lang="en-US" sz="1300" dirty="0"/>
           </a:p>
@@ -4360,7 +3199,40 @@
                 <a:ea typeface="Cambria" pitchFamily="34" charset="-122"/>
                 <a:cs typeface="Cambria" pitchFamily="34" charset="-120"/>
               </a:rPr>
-              <a:t>GUI Prediksi</a:t>
+              <a:t>GUI </a:t>
+            </a:r>
+            <a:r>
+              <a:rPr lang="en-US" sz="2200" b="1" dirty="0" err="1">
+                <a:solidFill>
+                  <a:srgbClr val="FFFFFF"/>
+                </a:solidFill>
+                <a:latin typeface="Cambria" pitchFamily="34" charset="0"/>
+                <a:ea typeface="Cambria" pitchFamily="34" charset="-122"/>
+                <a:cs typeface="Cambria" pitchFamily="34" charset="-120"/>
+              </a:rPr>
+              <a:t>untuk</a:t>
+            </a:r>
+            <a:r>
+              <a:rPr lang="en-US" sz="2200" b="1" dirty="0">
+                <a:solidFill>
+                  <a:srgbClr val="FFFFFF"/>
+                </a:solidFill>
+                <a:latin typeface="Cambria" pitchFamily="34" charset="0"/>
+                <a:ea typeface="Cambria" pitchFamily="34" charset="-122"/>
+                <a:cs typeface="Cambria" pitchFamily="34" charset="-120"/>
+              </a:rPr>
+              <a:t> </a:t>
+            </a:r>
+            <a:r>
+              <a:rPr lang="en-US" sz="2200" b="1" dirty="0" err="1">
+                <a:solidFill>
+                  <a:srgbClr val="FFFFFF"/>
+                </a:solidFill>
+                <a:latin typeface="Cambria" pitchFamily="34" charset="0"/>
+                <a:ea typeface="Cambria" pitchFamily="34" charset="-122"/>
+                <a:cs typeface="Cambria" pitchFamily="34" charset="-120"/>
+              </a:rPr>
+              <a:t>Prediksi</a:t>
             </a:r>
             <a:endParaRPr lang="en-US" sz="2200" dirty="0"/>
           </a:p>
@@ -4564,7 +3436,7 @@
                 <a:ea typeface="Courier New" pitchFamily="34" charset="-122"/>
                 <a:cs typeface="Courier New" pitchFamily="34" charset="-120"/>
               </a:rPr>
-              <a:t>gui_predict.py</a:t>
+              <a:t>app_browser.py</a:t>
             </a:r>
             <a:endParaRPr lang="en-US" sz="1400" dirty="0"/>
           </a:p>
@@ -4657,21 +3529,22 @@
           <a:bodyPr wrap="square" rtlCol="0" anchor="ctr"/>
           <a:lstStyle/>
           <a:p>
-            <a:pPr marL="0" indent="0">
-              <a:buNone/>
-            </a:pPr>
-            <a:r>
-              <a:rPr lang="en-US" sz="1200" dirty="0">
-                <a:solidFill>
-                  <a:srgbClr val="7EFFD3"/>
-                </a:solidFill>
-                <a:latin typeface="Courier New" pitchFamily="34" charset="0"/>
-                <a:ea typeface="Courier New" pitchFamily="34" charset="-122"/>
-                <a:cs typeface="Courier New" pitchFamily="34" charset="-120"/>
-              </a:rPr>
-              <a:t>python gui_predict.py</a:t>
-            </a:r>
-            <a:endParaRPr lang="en-US" sz="1200" dirty="0"/>
+            <a:r>
+              <a:rPr lang="en-ID" dirty="0" err="1">
+                <a:solidFill>
+                  <a:srgbClr val="2ECC8F"/>
+                </a:solidFill>
+              </a:rPr>
+              <a:t>streamlit</a:t>
+            </a:r>
+            <a:r>
+              <a:rPr lang="en-ID" dirty="0">
+                <a:solidFill>
+                  <a:srgbClr val="2ECC8F"/>
+                </a:solidFill>
+              </a:rPr>
+              <a:t> run app_browser.py</a:t>
+            </a:r>
           </a:p>
         </p:txBody>
       </p:sp>
@@ -4684,7 +3557,7 @@
         <p:spPr>
           <a:xfrm>
             <a:off x="4663440" y="1005840"/>
-            <a:ext cx="4069080" cy="3840480"/>
+            <a:ext cx="4069080" cy="1828800"/>
           </a:xfrm>
           <a:prstGeom prst="roundRect">
             <a:avLst>
@@ -4722,7 +3595,7 @@
           </a:xfrm>
           <a:prstGeom prst="roundRect">
             <a:avLst>
-              <a:gd name="adj" fmla="val 26316"/>
+              <a:gd name="adj" fmla="val 16036"/>
             </a:avLst>
           </a:prstGeom>
           <a:solidFill>
@@ -4780,8 +3653,8 @@
         </p:nvSpPr>
         <p:spPr>
           <a:xfrm>
-            <a:off x="4846320" y="1481328"/>
-            <a:ext cx="3749040" cy="475488"/>
+            <a:off x="4846320" y="1405128"/>
+            <a:ext cx="3749040" cy="226423"/>
           </a:xfrm>
           <a:prstGeom prst="rect">
             <a:avLst/>
@@ -4797,9 +3670,9 @@
               <a:buNone/>
             </a:pPr>
             <a:r>
-              <a:rPr lang="en-US" sz="1300" dirty="0">
-                <a:solidFill>
-                  <a:srgbClr val="1E2D27"/>
+              <a:rPr lang="en-US" sz="1200" dirty="0">
+                <a:solidFill>
+                  <a:srgbClr val="2ECC8F"/>
                 </a:solidFill>
                 <a:latin typeface="Calibri" pitchFamily="34" charset="0"/>
                 <a:ea typeface="Calibri" pitchFamily="34" charset="-122"/>
@@ -4807,7 +3680,11 @@
               </a:rPr>
               <a:t>📂  Pilih model .pt</a:t>
             </a:r>
-            <a:endParaRPr lang="en-US" sz="1300" dirty="0"/>
+            <a:endParaRPr lang="en-US" sz="1200" dirty="0">
+              <a:solidFill>
+                <a:srgbClr val="2ECC8F"/>
+              </a:solidFill>
+            </a:endParaRPr>
           </a:p>
         </p:txBody>
       </p:sp>
@@ -4819,8 +3696,8 @@
         </p:nvSpPr>
         <p:spPr>
           <a:xfrm>
-            <a:off x="4846320" y="2029968"/>
-            <a:ext cx="3749040" cy="475488"/>
+            <a:off x="4846320" y="1627632"/>
+            <a:ext cx="3749040" cy="226423"/>
           </a:xfrm>
           <a:prstGeom prst="rect">
             <a:avLst/>
@@ -4836,9 +3713,9 @@
               <a:buNone/>
             </a:pPr>
             <a:r>
-              <a:rPr lang="en-US" sz="1300" dirty="0">
-                <a:solidFill>
-                  <a:srgbClr val="1E2D27"/>
+              <a:rPr lang="en-US" sz="1200" dirty="0">
+                <a:solidFill>
+                  <a:srgbClr val="2ECC8F"/>
                 </a:solidFill>
                 <a:latin typeface="Calibri" pitchFamily="34" charset="0"/>
                 <a:ea typeface="Calibri" pitchFamily="34" charset="-122"/>
@@ -4846,7 +3723,11 @@
               </a:rPr>
               <a:t>🖼️  Pilih gambar</a:t>
             </a:r>
-            <a:endParaRPr lang="en-US" sz="1300" dirty="0"/>
+            <a:endParaRPr lang="en-US" sz="1200" dirty="0">
+              <a:solidFill>
+                <a:srgbClr val="2ECC8F"/>
+              </a:solidFill>
+            </a:endParaRPr>
           </a:p>
         </p:txBody>
       </p:sp>
@@ -4858,8 +3739,8 @@
         </p:nvSpPr>
         <p:spPr>
           <a:xfrm>
-            <a:off x="4846320" y="2578608"/>
-            <a:ext cx="3749040" cy="475488"/>
+            <a:off x="4846320" y="1859280"/>
+            <a:ext cx="3749040" cy="226423"/>
           </a:xfrm>
           <a:prstGeom prst="rect">
             <a:avLst/>
@@ -4875,9 +3756,9 @@
               <a:buNone/>
             </a:pPr>
             <a:r>
-              <a:rPr lang="en-US" sz="1300" dirty="0">
-                <a:solidFill>
-                  <a:srgbClr val="1E2D27"/>
+              <a:rPr lang="en-US" sz="1200" dirty="0">
+                <a:solidFill>
+                  <a:srgbClr val="2ECC8F"/>
                 </a:solidFill>
                 <a:latin typeface="Calibri" pitchFamily="34" charset="0"/>
                 <a:ea typeface="Calibri" pitchFamily="34" charset="-122"/>
@@ -4885,7 +3766,11 @@
               </a:rPr>
               <a:t>🎚️  Atur confidence threshold</a:t>
             </a:r>
-            <a:endParaRPr lang="en-US" sz="1300" dirty="0"/>
+            <a:endParaRPr lang="en-US" sz="1200" dirty="0">
+              <a:solidFill>
+                <a:srgbClr val="2ECC8F"/>
+              </a:solidFill>
+            </a:endParaRPr>
           </a:p>
         </p:txBody>
       </p:sp>
@@ -4897,8 +3782,8 @@
         </p:nvSpPr>
         <p:spPr>
           <a:xfrm>
-            <a:off x="4846320" y="3127248"/>
-            <a:ext cx="3749040" cy="475488"/>
+            <a:off x="4846320" y="2085703"/>
+            <a:ext cx="3749040" cy="226423"/>
           </a:xfrm>
           <a:prstGeom prst="rect">
             <a:avLst/>
@@ -4914,9 +3799,9 @@
               <a:buNone/>
             </a:pPr>
             <a:r>
-              <a:rPr lang="en-US" sz="1300" dirty="0">
-                <a:solidFill>
-                  <a:srgbClr val="1E2D27"/>
+              <a:rPr lang="en-US" sz="1200" dirty="0">
+                <a:solidFill>
+                  <a:srgbClr val="2ECC8F"/>
                 </a:solidFill>
                 <a:latin typeface="Calibri" pitchFamily="34" charset="0"/>
                 <a:ea typeface="Calibri" pitchFamily="34" charset="-122"/>
@@ -4924,7 +3809,11 @@
               </a:rPr>
               <a:t>🔍  Prediksi jenis beras</a:t>
             </a:r>
-            <a:endParaRPr lang="en-US" sz="1300" dirty="0"/>
+            <a:endParaRPr lang="en-US" sz="1200" dirty="0">
+              <a:solidFill>
+                <a:srgbClr val="2ECC8F"/>
+              </a:solidFill>
+            </a:endParaRPr>
           </a:p>
         </p:txBody>
       </p:sp>
@@ -4936,8 +3825,8 @@
         </p:nvSpPr>
         <p:spPr>
           <a:xfrm>
-            <a:off x="4846320" y="3675888"/>
-            <a:ext cx="3749040" cy="475488"/>
+            <a:off x="4846320" y="2315391"/>
+            <a:ext cx="3749040" cy="226423"/>
           </a:xfrm>
           <a:prstGeom prst="rect">
             <a:avLst/>
@@ -4953,9 +3842,9 @@
               <a:buNone/>
             </a:pPr>
             <a:r>
-              <a:rPr lang="en-US" sz="1300" dirty="0">
-                <a:solidFill>
-                  <a:srgbClr val="1E2D27"/>
+              <a:rPr lang="en-US" sz="1200" dirty="0">
+                <a:solidFill>
+                  <a:srgbClr val="2ECC8F"/>
                 </a:solidFill>
                 <a:latin typeface="Calibri" pitchFamily="34" charset="0"/>
                 <a:ea typeface="Calibri" pitchFamily="34" charset="-122"/>
@@ -4963,7 +3852,11 @@
               </a:rPr>
               <a:t>📦  Tampilkan bounding box</a:t>
             </a:r>
-            <a:endParaRPr lang="en-US" sz="1300" dirty="0"/>
+            <a:endParaRPr lang="en-US" sz="1200" dirty="0">
+              <a:solidFill>
+                <a:srgbClr val="2ECC8F"/>
+              </a:solidFill>
+            </a:endParaRPr>
           </a:p>
         </p:txBody>
       </p:sp>
@@ -4975,8 +3868,8 @@
         </p:nvSpPr>
         <p:spPr>
           <a:xfrm>
-            <a:off x="4846320" y="4224528"/>
-            <a:ext cx="3749040" cy="475488"/>
+            <a:off x="4846320" y="2545080"/>
+            <a:ext cx="3749040" cy="226423"/>
           </a:xfrm>
           <a:prstGeom prst="rect">
             <a:avLst/>
@@ -4992,850 +3885,62 @@
               <a:buNone/>
             </a:pPr>
             <a:r>
-              <a:rPr lang="en-US" sz="1300" dirty="0">
-                <a:solidFill>
-                  <a:srgbClr val="1E2D27"/>
+              <a:rPr lang="en-US" sz="1200" dirty="0">
+                <a:solidFill>
+                  <a:srgbClr val="2ECC8F"/>
                 </a:solidFill>
                 <a:latin typeface="Calibri" pitchFamily="34" charset="0"/>
                 <a:ea typeface="Calibri" pitchFamily="34" charset="-122"/>
                 <a:cs typeface="Calibri" pitchFamily="34" charset="-120"/>
               </a:rPr>
-              <a:t>💾  Simpan hasil otomatis</a:t>
-            </a:r>
-            <a:endParaRPr lang="en-US" sz="1300" dirty="0"/>
-          </a:p>
-        </p:txBody>
-      </p:sp>
-    </p:spTree>
-  </p:cSld>
-  <p:clrMapOvr>
-    <a:masterClrMapping/>
-  </p:clrMapOvr>
-</p:sld>
-</file>
-
-<file path=ppt/slides/slide13.xml><?xml version="1.0" encoding="utf-8"?>
-<p:sld xmlns:a="http://schemas.openxmlformats.org/drawingml/2006/main" xmlns:r="http://schemas.openxmlformats.org/officeDocument/2006/relationships" xmlns:p="http://schemas.openxmlformats.org/presentationml/2006/main">
-  <p:cSld name="Slide 13">
-    <p:bg>
-      <p:bgPr>
-        <a:solidFill>
-          <a:srgbClr val="FFFFFF"/>
-        </a:solidFill>
-        <a:effectLst/>
-      </p:bgPr>
-    </p:bg>
-    <p:spTree>
-      <p:nvGrpSpPr>
-        <p:cNvPr id="1" name=""/>
-        <p:cNvGrpSpPr/>
-        <p:nvPr/>
-      </p:nvGrpSpPr>
-      <p:grpSpPr>
-        <a:xfrm>
-          <a:off x="0" y="0"/>
-          <a:ext cx="0" cy="0"/>
-          <a:chOff x="0" y="0"/>
-          <a:chExt cx="0" cy="0"/>
-        </a:xfrm>
-      </p:grpSpPr>
-      <p:sp>
-        <p:nvSpPr>
-          <p:cNvPr id="2" name="Shape 0"/>
-          <p:cNvSpPr/>
-          <p:nvPr/>
-        </p:nvSpPr>
-        <p:spPr>
-          <a:xfrm>
-            <a:off x="0" y="0"/>
-            <a:ext cx="9144000" cy="914400"/>
-          </a:xfrm>
-          <a:prstGeom prst="rect">
-            <a:avLst/>
-          </a:prstGeom>
-          <a:solidFill>
-            <a:srgbClr val="0D3B2E"/>
-          </a:solidFill>
-          <a:ln w="12700">
-            <a:solidFill>
-              <a:srgbClr val="0D3B2E"/>
-            </a:solidFill>
-            <a:prstDash val="solid"/>
-          </a:ln>
-        </p:spPr>
-      </p:sp>
-      <p:sp>
-        <p:nvSpPr>
-          <p:cNvPr id="3" name="Shape 1"/>
-          <p:cNvSpPr/>
-          <p:nvPr/>
-        </p:nvSpPr>
-        <p:spPr>
-          <a:xfrm>
-            <a:off x="320040" y="137160"/>
-            <a:ext cx="457200" cy="457200"/>
-          </a:xfrm>
-          <a:prstGeom prst="roundRect">
-            <a:avLst>
-              <a:gd name="adj" fmla="val 12000"/>
-            </a:avLst>
-          </a:prstGeom>
-          <a:solidFill>
-            <a:srgbClr val="2ECC8F"/>
-          </a:solidFill>
-          <a:ln w="12700">
-            <a:solidFill>
-              <a:srgbClr val="2ECC8F"/>
-            </a:solidFill>
-            <a:prstDash val="solid"/>
-          </a:ln>
-        </p:spPr>
-      </p:sp>
-      <p:sp>
-        <p:nvSpPr>
-          <p:cNvPr id="4" name="Text 2"/>
-          <p:cNvSpPr/>
-          <p:nvPr/>
-        </p:nvSpPr>
-        <p:spPr>
-          <a:xfrm>
-            <a:off x="320040" y="137160"/>
-            <a:ext cx="457200" cy="457200"/>
-          </a:xfrm>
-          <a:prstGeom prst="rect">
-            <a:avLst/>
-          </a:prstGeom>
-          <a:noFill/>
-          <a:ln/>
-        </p:spPr>
-        <p:txBody>
-          <a:bodyPr wrap="square" lIns="0" tIns="0" rIns="0" bIns="0" rtlCol="0" anchor="ctr"/>
-          <a:lstStyle/>
-          <a:p>
-            <a:pPr marL="0" indent="0" algn="ctr">
-              <a:buNone/>
-            </a:pPr>
-            <a:r>
-              <a:rPr lang="en-US" sz="1300" b="1" dirty="0">
-                <a:solidFill>
-                  <a:srgbClr val="0D3B2E"/>
-                </a:solidFill>
-              </a:rPr>
-              <a:t>13</a:t>
-            </a:r>
-            <a:endParaRPr lang="en-US" sz="1300" dirty="0"/>
-          </a:p>
-        </p:txBody>
-      </p:sp>
-      <p:sp>
-        <p:nvSpPr>
-          <p:cNvPr id="5" name="Text 3"/>
-          <p:cNvSpPr/>
-          <p:nvPr/>
-        </p:nvSpPr>
-        <p:spPr>
-          <a:xfrm>
-            <a:off x="914400" y="109728"/>
-            <a:ext cx="7955280" cy="694944"/>
-          </a:xfrm>
-          <a:prstGeom prst="rect">
-            <a:avLst/>
-          </a:prstGeom>
-          <a:noFill/>
-          <a:ln/>
-        </p:spPr>
-        <p:txBody>
-          <a:bodyPr wrap="square" rtlCol="0" anchor="ctr"/>
-          <a:lstStyle/>
-          <a:p>
-            <a:pPr marL="0" indent="0">
-              <a:buNone/>
-            </a:pPr>
-            <a:r>
-              <a:rPr lang="en-US" sz="2200" b="1" dirty="0">
-                <a:solidFill>
-                  <a:srgbClr val="FFFFFF"/>
-                </a:solidFill>
-                <a:latin typeface="Cambria" pitchFamily="34" charset="0"/>
-                <a:ea typeface="Cambria" pitchFamily="34" charset="-122"/>
-                <a:cs typeface="Cambria" pitchFamily="34" charset="-120"/>
-              </a:rPr>
-              <a:t>Perbaikan Bounding Box di GUI</a:t>
-            </a:r>
-            <a:endParaRPr lang="en-US" sz="2200" dirty="0"/>
-          </a:p>
-        </p:txBody>
-      </p:sp>
-      <p:sp>
-        <p:nvSpPr>
-          <p:cNvPr id="6" name="Shape 4"/>
-          <p:cNvSpPr/>
-          <p:nvPr/>
-        </p:nvSpPr>
-        <p:spPr>
-          <a:xfrm>
-            <a:off x="7863840" y="-274320"/>
-            <a:ext cx="1463040" cy="1463040"/>
-          </a:xfrm>
-          <a:prstGeom prst="ellipse">
-            <a:avLst/>
-          </a:prstGeom>
-          <a:solidFill>
-            <a:srgbClr val="2ECC8F">
-              <a:alpha val="20000"/>
-            </a:srgbClr>
-          </a:solidFill>
-          <a:ln w="12700">
-            <a:solidFill>
-              <a:srgbClr val="2ECC8F">
-                <a:alpha val="20000"/>
-              </a:srgbClr>
-            </a:solidFill>
-            <a:prstDash val="solid"/>
-          </a:ln>
-        </p:spPr>
-      </p:sp>
-      <p:sp>
-        <p:nvSpPr>
-          <p:cNvPr id="7" name="Text 5"/>
-          <p:cNvSpPr/>
-          <p:nvPr/>
-        </p:nvSpPr>
-        <p:spPr>
-          <a:xfrm>
-            <a:off x="457200" y="1005840"/>
-            <a:ext cx="8229600" cy="548640"/>
-          </a:xfrm>
-          <a:prstGeom prst="rect">
-            <a:avLst/>
-          </a:prstGeom>
-          <a:noFill/>
-          <a:ln/>
-        </p:spPr>
-        <p:txBody>
-          <a:bodyPr wrap="square" rtlCol="0" anchor="ctr"/>
-          <a:lstStyle/>
-          <a:p>
-            <a:pPr marL="0" indent="0">
-              <a:buNone/>
-            </a:pPr>
-            <a:r>
-              <a:rPr lang="en-US" sz="1350" dirty="0">
-                <a:solidFill>
-                  <a:srgbClr val="5A7A6E"/>
+              <a:t>💾  Simpan </a:t>
+            </a:r>
+            <a:r>
+              <a:rPr lang="en-US" sz="1200" dirty="0" err="1">
+                <a:solidFill>
+                  <a:srgbClr val="2ECC8F"/>
                 </a:solidFill>
                 <a:latin typeface="Calibri" pitchFamily="34" charset="0"/>
                 <a:ea typeface="Calibri" pitchFamily="34" charset="-122"/>
                 <a:cs typeface="Calibri" pitchFamily="34" charset="-120"/>
               </a:rPr>
-              <a:t>Karena label awal bersifat full-frame, bounding box dari model bisa terlalu besar dan tidak presisi.</a:t>
-            </a:r>
-            <a:endParaRPr lang="en-US" sz="1350" dirty="0"/>
-          </a:p>
-        </p:txBody>
-      </p:sp>
-      <p:sp>
-        <p:nvSpPr>
-          <p:cNvPr id="8" name="Shape 6"/>
-          <p:cNvSpPr/>
-          <p:nvPr/>
-        </p:nvSpPr>
-        <p:spPr>
-          <a:xfrm>
-            <a:off x="411480" y="1600200"/>
-            <a:ext cx="4023360" cy="3200400"/>
-          </a:xfrm>
-          <a:prstGeom prst="roundRect">
-            <a:avLst>
-              <a:gd name="adj" fmla="val 2857"/>
-            </a:avLst>
-          </a:prstGeom>
-          <a:solidFill>
-            <a:srgbClr val="FFF0F0"/>
-          </a:solidFill>
-          <a:ln w="10160">
-            <a:solidFill>
-              <a:srgbClr val="FFAAAA"/>
-            </a:solidFill>
-            <a:prstDash val="solid"/>
-          </a:ln>
-          <a:effectLst>
-            <a:outerShdw blurRad="101600" dist="38100" dir="2700000" algn="bl" rotWithShape="0">
-              <a:srgbClr val="000000">
-                <a:alpha val="12000"/>
-              </a:srgbClr>
-            </a:outerShdw>
-          </a:effectLst>
-        </p:spPr>
-      </p:sp>
-      <p:sp>
-        <p:nvSpPr>
-          <p:cNvPr id="9" name="Shape 7"/>
-          <p:cNvSpPr/>
-          <p:nvPr/>
-        </p:nvSpPr>
-        <p:spPr>
-          <a:xfrm>
-            <a:off x="411480" y="1600200"/>
-            <a:ext cx="4023360" cy="457200"/>
-          </a:xfrm>
-          <a:prstGeom prst="roundRect">
-            <a:avLst>
-              <a:gd name="adj" fmla="val 20000"/>
-            </a:avLst>
-          </a:prstGeom>
-          <a:solidFill>
-            <a:srgbClr val="E05555"/>
-          </a:solidFill>
-          <a:ln w="12700">
-            <a:solidFill>
-              <a:srgbClr val="E05555"/>
-            </a:solidFill>
-            <a:prstDash val="solid"/>
-          </a:ln>
-        </p:spPr>
-      </p:sp>
-      <p:sp>
-        <p:nvSpPr>
-          <p:cNvPr id="10" name="Text 8"/>
-          <p:cNvSpPr/>
-          <p:nvPr/>
-        </p:nvSpPr>
-        <p:spPr>
-          <a:xfrm>
-            <a:off x="548640" y="1600200"/>
-            <a:ext cx="3840480" cy="457200"/>
-          </a:xfrm>
-          <a:prstGeom prst="rect">
-            <a:avLst/>
-          </a:prstGeom>
-          <a:noFill/>
-          <a:ln/>
-        </p:spPr>
-        <p:txBody>
-          <a:bodyPr wrap="square" rtlCol="0" anchor="ctr"/>
-          <a:lstStyle/>
-          <a:p>
-            <a:pPr marL="0" indent="0">
-              <a:buNone/>
-            </a:pPr>
-            <a:r>
-              <a:rPr lang="en-US" sz="1300" b="1" dirty="0">
-                <a:solidFill>
-                  <a:srgbClr val="FFFFFF"/>
-                </a:solidFill>
-              </a:rPr>
-              <a:t>❌  Masalah</a:t>
-            </a:r>
-            <a:endParaRPr lang="en-US" sz="1300" dirty="0"/>
-          </a:p>
-        </p:txBody>
-      </p:sp>
-      <p:sp>
-        <p:nvSpPr>
-          <p:cNvPr id="11" name="Text 9"/>
-          <p:cNvSpPr/>
-          <p:nvPr/>
-        </p:nvSpPr>
-        <p:spPr>
-          <a:xfrm>
-            <a:off x="640080" y="2176272"/>
-            <a:ext cx="3566160" cy="2468880"/>
-          </a:xfrm>
-          <a:prstGeom prst="rect">
-            <a:avLst/>
-          </a:prstGeom>
-          <a:noFill/>
-          <a:ln/>
-        </p:spPr>
-        <p:txBody>
-          <a:bodyPr wrap="square" rtlCol="0" anchor="ctr"/>
-          <a:lstStyle/>
-          <a:p>
-            <a:pPr marL="342900" indent="-342900">
-              <a:buSzPct val="100000"/>
-              <a:buChar char="•"/>
-            </a:pPr>
-            <a:r>
-              <a:rPr lang="en-US" sz="1300" dirty="0">
-                <a:solidFill>
-                  <a:srgbClr val="1E2D27"/>
+              <a:t>hasil</a:t>
+            </a:r>
+            <a:r>
+              <a:rPr lang="en-US" sz="1200" dirty="0">
+                <a:solidFill>
+                  <a:srgbClr val="2ECC8F"/>
                 </a:solidFill>
                 <a:latin typeface="Calibri" pitchFamily="34" charset="0"/>
                 <a:ea typeface="Calibri" pitchFamily="34" charset="-122"/>
                 <a:cs typeface="Calibri" pitchFamily="34" charset="-120"/>
               </a:rPr>
-              <a:t>Box dari model terlalu besar</a:t>
-            </a:r>
-            <a:endParaRPr lang="en-US" sz="1300" dirty="0"/>
-          </a:p>
-          <a:p>
-            <a:pPr marL="342900" indent="-342900">
-              <a:buSzPct val="100000"/>
-              <a:buChar char="•"/>
-            </a:pPr>
-            <a:r>
-              <a:rPr lang="en-US" sz="1300" dirty="0">
-                <a:solidFill>
-                  <a:srgbClr val="1E2D27"/>
-                </a:solidFill>
-                <a:latin typeface="Calibri" pitchFamily="34" charset="0"/>
-                <a:ea typeface="Calibri" pitchFamily="34" charset="-122"/>
-                <a:cs typeface="Calibri" pitchFamily="34" charset="-120"/>
-              </a:rPr>
-              <a:t>Tidak akurat menunjuk area beras</a:t>
-            </a:r>
-            <a:endParaRPr lang="en-US" sz="1300" dirty="0"/>
-          </a:p>
-          <a:p>
-            <a:pPr marL="342900" indent="-342900">
-              <a:buSzPct val="100000"/>
-              <a:buChar char="•"/>
-            </a:pPr>
-            <a:r>
-              <a:rPr lang="en-US" sz="1300" dirty="0">
-                <a:solidFill>
-                  <a:srgbClr val="1E2D27"/>
-                </a:solidFill>
-                <a:latin typeface="Calibri" pitchFamily="34" charset="0"/>
-                <a:ea typeface="Calibri" pitchFamily="34" charset="-122"/>
-                <a:cs typeface="Calibri" pitchFamily="34" charset="-120"/>
-              </a:rPr>
-              <a:t>Label awal full-frame dari preprocessing</a:t>
-            </a:r>
-            <a:endParaRPr lang="en-US" sz="1300" dirty="0"/>
-          </a:p>
-        </p:txBody>
-      </p:sp>
-      <p:sp>
-        <p:nvSpPr>
-          <p:cNvPr id="12" name="Shape 10"/>
-          <p:cNvSpPr/>
-          <p:nvPr/>
-        </p:nvSpPr>
-        <p:spPr>
-          <a:xfrm>
-            <a:off x="4709160" y="1600200"/>
-            <a:ext cx="4023360" cy="3200400"/>
-          </a:xfrm>
-          <a:prstGeom prst="roundRect">
-            <a:avLst>
-              <a:gd name="adj" fmla="val 2857"/>
-            </a:avLst>
-          </a:prstGeom>
-          <a:solidFill>
-            <a:srgbClr val="E8F5F0"/>
-          </a:solidFill>
-          <a:ln w="10160">
-            <a:solidFill>
-              <a:srgbClr val="2ECC8F"/>
-            </a:solidFill>
-            <a:prstDash val="solid"/>
-          </a:ln>
-          <a:effectLst>
-            <a:outerShdw blurRad="101600" dist="38100" dir="2700000" algn="bl" rotWithShape="0">
-              <a:srgbClr val="000000">
-                <a:alpha val="12000"/>
-              </a:srgbClr>
-            </a:outerShdw>
-          </a:effectLst>
-        </p:spPr>
-      </p:sp>
-      <p:sp>
-        <p:nvSpPr>
-          <p:cNvPr id="13" name="Shape 11"/>
-          <p:cNvSpPr/>
-          <p:nvPr/>
-        </p:nvSpPr>
-        <p:spPr>
-          <a:xfrm>
-            <a:off x="4709160" y="1600200"/>
-            <a:ext cx="4023360" cy="457200"/>
-          </a:xfrm>
-          <a:prstGeom prst="roundRect">
-            <a:avLst>
-              <a:gd name="adj" fmla="val 20000"/>
-            </a:avLst>
-          </a:prstGeom>
-          <a:solidFill>
-            <a:srgbClr val="1A6B4A"/>
-          </a:solidFill>
-          <a:ln w="12700">
-            <a:solidFill>
-              <a:srgbClr val="1A6B4A"/>
-            </a:solidFill>
-            <a:prstDash val="solid"/>
-          </a:ln>
-        </p:spPr>
-      </p:sp>
-      <p:sp>
-        <p:nvSpPr>
-          <p:cNvPr id="14" name="Text 12"/>
-          <p:cNvSpPr/>
-          <p:nvPr/>
-        </p:nvSpPr>
-        <p:spPr>
-          <a:xfrm>
-            <a:off x="4846320" y="1600200"/>
-            <a:ext cx="3840480" cy="457200"/>
-          </a:xfrm>
-          <a:prstGeom prst="rect">
-            <a:avLst/>
-          </a:prstGeom>
-          <a:noFill/>
-          <a:ln/>
-        </p:spPr>
-        <p:txBody>
-          <a:bodyPr wrap="square" rtlCol="0" anchor="ctr"/>
-          <a:lstStyle/>
-          <a:p>
-            <a:pPr marL="0" indent="0">
-              <a:buNone/>
-            </a:pPr>
-            <a:r>
-              <a:rPr lang="en-US" sz="1300" b="1" dirty="0">
-                <a:solidFill>
-                  <a:srgbClr val="FFFFFF"/>
-                </a:solidFill>
-              </a:rPr>
-              <a:t>✅  Solusi Post-processing</a:t>
-            </a:r>
-            <a:endParaRPr lang="en-US" sz="1300" dirty="0"/>
-          </a:p>
-        </p:txBody>
-      </p:sp>
-      <p:sp>
-        <p:nvSpPr>
-          <p:cNvPr id="15" name="Text 13"/>
-          <p:cNvSpPr/>
-          <p:nvPr/>
-        </p:nvSpPr>
-        <p:spPr>
-          <a:xfrm>
-            <a:off x="4892040" y="2176272"/>
-            <a:ext cx="3703320" cy="2468880"/>
-          </a:xfrm>
-          <a:prstGeom prst="rect">
-            <a:avLst/>
-          </a:prstGeom>
-          <a:noFill/>
-          <a:ln/>
-        </p:spPr>
-        <p:txBody>
-          <a:bodyPr wrap="square" rtlCol="0" anchor="ctr"/>
-          <a:lstStyle/>
-          <a:p>
-            <a:pPr marL="342900" indent="-342900">
-              <a:buSzPct val="100000"/>
-              <a:buChar char="•"/>
-            </a:pPr>
-            <a:r>
-              <a:rPr lang="en-US" sz="1300" dirty="0">
-                <a:solidFill>
-                  <a:srgbClr val="1E2D27"/>
-                </a:solidFill>
-                <a:latin typeface="Calibri" pitchFamily="34" charset="0"/>
-                <a:ea typeface="Calibri" pitchFamily="34" charset="-122"/>
-                <a:cs typeface="Calibri" pitchFamily="34" charset="-120"/>
-              </a:rPr>
-              <a:t>Deteksi area beras dari warna/threshold</a:t>
-            </a:r>
-            <a:endParaRPr lang="en-US" sz="1300" dirty="0"/>
-          </a:p>
-          <a:p>
-            <a:pPr marL="342900" indent="-342900">
-              <a:buSzPct val="100000"/>
-              <a:buChar char="•"/>
-            </a:pPr>
-            <a:r>
-              <a:rPr lang="en-US" sz="1300" dirty="0">
-                <a:solidFill>
-                  <a:srgbClr val="1E2D27"/>
-                </a:solidFill>
-                <a:latin typeface="Calibri" pitchFamily="34" charset="0"/>
-                <a:ea typeface="Calibri" pitchFamily="34" charset="-122"/>
-                <a:cs typeface="Calibri" pitchFamily="34" charset="-120"/>
-              </a:rPr>
-              <a:t>Mengabaikan noise kecil</a:t>
-            </a:r>
-            <a:endParaRPr lang="en-US" sz="1300" dirty="0"/>
-          </a:p>
-          <a:p>
-            <a:pPr marL="342900" indent="-342900">
-              <a:buSzPct val="100000"/>
-              <a:buChar char="•"/>
-            </a:pPr>
-            <a:r>
-              <a:rPr lang="en-US" sz="1300" dirty="0">
-                <a:solidFill>
-                  <a:srgbClr val="1E2D27"/>
-                </a:solidFill>
-                <a:latin typeface="Calibri" pitchFamily="34" charset="0"/>
-                <a:ea typeface="Calibri" pitchFamily="34" charset="-122"/>
-                <a:cs typeface="Calibri" pitchFamily="34" charset="-120"/>
-              </a:rPr>
-              <a:t>Membuat bounding box yang lebih rapat</a:t>
-            </a:r>
-            <a:endParaRPr lang="en-US" sz="1300" dirty="0"/>
-          </a:p>
-          <a:p>
-            <a:pPr marL="342900" indent="-342900">
-              <a:buSzPct val="100000"/>
-              <a:buChar char="•"/>
-            </a:pPr>
-            <a:r>
-              <a:rPr lang="en-US" sz="1300" dirty="0">
-                <a:solidFill>
-                  <a:srgbClr val="1E2D27"/>
-                </a:solidFill>
-                <a:latin typeface="Calibri" pitchFamily="34" charset="0"/>
-                <a:ea typeface="Calibri" pitchFamily="34" charset="-122"/>
-                <a:cs typeface="Calibri" pitchFamily="34" charset="-120"/>
-              </a:rPr>
-              <a:t>Opsi GUI: Box menyesuaikan beras</a:t>
-            </a:r>
-            <a:endParaRPr lang="en-US" sz="1300" dirty="0"/>
-          </a:p>
-        </p:txBody>
-      </p:sp>
-    </p:spTree>
-  </p:cSld>
-  <p:clrMapOvr>
-    <a:masterClrMapping/>
-  </p:clrMapOvr>
-</p:sld>
-</file>
-
-<file path=ppt/slides/slide14.xml><?xml version="1.0" encoding="utf-8"?>
-<p:sld xmlns:a="http://schemas.openxmlformats.org/drawingml/2006/main" xmlns:r="http://schemas.openxmlformats.org/officeDocument/2006/relationships" xmlns:p="http://schemas.openxmlformats.org/presentationml/2006/main">
-  <p:cSld name="Slide 14">
-    <p:bg>
-      <p:bgPr>
-        <a:solidFill>
-          <a:srgbClr val="FFFFFF"/>
-        </a:solidFill>
-        <a:effectLst/>
-      </p:bgPr>
-    </p:bg>
-    <p:spTree>
-      <p:nvGrpSpPr>
-        <p:cNvPr id="1" name=""/>
-        <p:cNvGrpSpPr/>
-        <p:nvPr/>
-      </p:nvGrpSpPr>
-      <p:grpSpPr>
-        <a:xfrm>
-          <a:off x="0" y="0"/>
-          <a:ext cx="0" cy="0"/>
-          <a:chOff x="0" y="0"/>
-          <a:chExt cx="0" cy="0"/>
-        </a:xfrm>
-      </p:grpSpPr>
-      <p:sp>
-        <p:nvSpPr>
-          <p:cNvPr id="2" name="Shape 0"/>
-          <p:cNvSpPr/>
-          <p:nvPr/>
-        </p:nvSpPr>
-        <p:spPr>
-          <a:xfrm>
-            <a:off x="0" y="0"/>
-            <a:ext cx="9144000" cy="914400"/>
-          </a:xfrm>
-          <a:prstGeom prst="rect">
-            <a:avLst/>
-          </a:prstGeom>
-          <a:solidFill>
-            <a:srgbClr val="0D3B2E"/>
-          </a:solidFill>
-          <a:ln w="12700">
-            <a:solidFill>
-              <a:srgbClr val="0D3B2E"/>
-            </a:solidFill>
-            <a:prstDash val="solid"/>
-          </a:ln>
-        </p:spPr>
-      </p:sp>
-      <p:sp>
-        <p:nvSpPr>
-          <p:cNvPr id="3" name="Shape 1"/>
-          <p:cNvSpPr/>
-          <p:nvPr/>
-        </p:nvSpPr>
-        <p:spPr>
-          <a:xfrm>
-            <a:off x="320040" y="137160"/>
-            <a:ext cx="457200" cy="457200"/>
-          </a:xfrm>
-          <a:prstGeom prst="roundRect">
-            <a:avLst>
-              <a:gd name="adj" fmla="val 12000"/>
-            </a:avLst>
-          </a:prstGeom>
-          <a:solidFill>
-            <a:srgbClr val="2ECC8F"/>
-          </a:solidFill>
-          <a:ln w="12700">
-            <a:solidFill>
-              <a:srgbClr val="2ECC8F"/>
-            </a:solidFill>
-            <a:prstDash val="solid"/>
-          </a:ln>
-        </p:spPr>
-      </p:sp>
-      <p:sp>
-        <p:nvSpPr>
-          <p:cNvPr id="4" name="Text 2"/>
-          <p:cNvSpPr/>
-          <p:nvPr/>
-        </p:nvSpPr>
-        <p:spPr>
-          <a:xfrm>
-            <a:off x="320040" y="137160"/>
-            <a:ext cx="457200" cy="457200"/>
-          </a:xfrm>
-          <a:prstGeom prst="rect">
-            <a:avLst/>
-          </a:prstGeom>
-          <a:noFill/>
-          <a:ln/>
-        </p:spPr>
-        <p:txBody>
-          <a:bodyPr wrap="square" lIns="0" tIns="0" rIns="0" bIns="0" rtlCol="0" anchor="ctr"/>
-          <a:lstStyle/>
-          <a:p>
-            <a:pPr marL="0" indent="0" algn="ctr">
-              <a:buNone/>
-            </a:pPr>
-            <a:r>
-              <a:rPr lang="en-US" sz="1300" b="1" dirty="0">
-                <a:solidFill>
-                  <a:srgbClr val="0D3B2E"/>
-                </a:solidFill>
-              </a:rPr>
-              <a:t>14</a:t>
-            </a:r>
-            <a:endParaRPr lang="en-US" sz="1300" dirty="0"/>
-          </a:p>
-        </p:txBody>
-      </p:sp>
-      <p:sp>
-        <p:nvSpPr>
-          <p:cNvPr id="5" name="Text 3"/>
-          <p:cNvSpPr/>
-          <p:nvPr/>
-        </p:nvSpPr>
-        <p:spPr>
-          <a:xfrm>
-            <a:off x="914400" y="109728"/>
-            <a:ext cx="7955280" cy="694944"/>
-          </a:xfrm>
-          <a:prstGeom prst="rect">
-            <a:avLst/>
-          </a:prstGeom>
-          <a:noFill/>
-          <a:ln/>
-        </p:spPr>
-        <p:txBody>
-          <a:bodyPr wrap="square" rtlCol="0" anchor="ctr"/>
-          <a:lstStyle/>
-          <a:p>
-            <a:pPr marL="0" indent="0">
-              <a:buNone/>
-            </a:pPr>
-            <a:r>
-              <a:rPr lang="en-US" sz="2200" b="1" dirty="0">
-                <a:solidFill>
-                  <a:srgbClr val="FFFFFF"/>
-                </a:solidFill>
-                <a:latin typeface="Cambria" pitchFamily="34" charset="0"/>
-                <a:ea typeface="Cambria" pitchFamily="34" charset="-122"/>
-                <a:cs typeface="Cambria" pitchFamily="34" charset="-120"/>
-              </a:rPr>
-              <a:t>Output Prediksi</a:t>
-            </a:r>
-            <a:endParaRPr lang="en-US" sz="2200" dirty="0"/>
-          </a:p>
-        </p:txBody>
-      </p:sp>
-      <p:sp>
-        <p:nvSpPr>
-          <p:cNvPr id="6" name="Shape 4"/>
-          <p:cNvSpPr/>
-          <p:nvPr/>
-        </p:nvSpPr>
-        <p:spPr>
-          <a:xfrm>
-            <a:off x="7863840" y="-274320"/>
-            <a:ext cx="1463040" cy="1463040"/>
-          </a:xfrm>
-          <a:prstGeom prst="ellipse">
-            <a:avLst/>
-          </a:prstGeom>
-          <a:solidFill>
-            <a:srgbClr val="2ECC8F">
-              <a:alpha val="20000"/>
-            </a:srgbClr>
-          </a:solidFill>
-          <a:ln w="12700">
-            <a:solidFill>
-              <a:srgbClr val="2ECC8F">
-                <a:alpha val="20000"/>
-              </a:srgbClr>
-            </a:solidFill>
-            <a:prstDash val="solid"/>
-          </a:ln>
-        </p:spPr>
-      </p:sp>
-      <p:sp>
-        <p:nvSpPr>
-          <p:cNvPr id="7" name="Text 5"/>
-          <p:cNvSpPr/>
-          <p:nvPr/>
-        </p:nvSpPr>
-        <p:spPr>
-          <a:xfrm>
-            <a:off x="457200" y="1005840"/>
-            <a:ext cx="8229600" cy="411480"/>
-          </a:xfrm>
-          <a:prstGeom prst="rect">
-            <a:avLst/>
-          </a:prstGeom>
-          <a:noFill/>
-          <a:ln/>
-        </p:spPr>
-        <p:txBody>
-          <a:bodyPr wrap="square" rtlCol="0" anchor="ctr"/>
-          <a:lstStyle/>
-          <a:p>
-            <a:pPr marL="0" indent="0">
-              <a:buNone/>
-            </a:pPr>
-            <a:r>
-              <a:rPr lang="en-US" sz="1350" dirty="0">
-                <a:solidFill>
-                  <a:srgbClr val="5A7A6E"/>
-                </a:solidFill>
-                <a:latin typeface="Calibri" pitchFamily="34" charset="0"/>
-                <a:ea typeface="Calibri" pitchFamily="34" charset="-122"/>
-                <a:cs typeface="Calibri" pitchFamily="34" charset="-120"/>
-              </a:rPr>
-              <a:t>Hasil prediksi otomatis disimpan berdasarkan kelas yang terdeteksi:</a:t>
-            </a:r>
-            <a:endParaRPr lang="en-US" sz="1350" dirty="0"/>
-          </a:p>
-        </p:txBody>
-      </p:sp>
-      <p:sp>
-        <p:nvSpPr>
-          <p:cNvPr id="8" name="Shape 6"/>
-          <p:cNvSpPr/>
-          <p:nvPr/>
-        </p:nvSpPr>
-        <p:spPr>
-          <a:xfrm>
-            <a:off x="411480" y="1481328"/>
-            <a:ext cx="3657600" cy="3291840"/>
+              <a:t> (optional)</a:t>
+            </a:r>
+            <a:endParaRPr lang="en-US" sz="1200" dirty="0">
+              <a:solidFill>
+                <a:srgbClr val="2ECC8F"/>
+              </a:solidFill>
+            </a:endParaRPr>
+          </a:p>
+        </p:txBody>
+      </p:sp>
+      <p:sp>
+        <p:nvSpPr>
+          <p:cNvPr id="57" name="Shape 6">
+            <a:extLst>
+              <a:ext uri="{FF2B5EF4-FFF2-40B4-BE49-F238E27FC236}">
+                <a16:creationId xmlns:a16="http://schemas.microsoft.com/office/drawing/2014/main" id="{5E2C883E-A67A-9F61-780F-60609E2196D2}"/>
+              </a:ext>
+            </a:extLst>
+          </p:cNvPr>
+          <p:cNvSpPr/>
+          <p:nvPr/>
+        </p:nvSpPr>
+        <p:spPr>
+          <a:xfrm>
+            <a:off x="2654096" y="3057144"/>
+            <a:ext cx="4114800" cy="1921256"/>
           </a:xfrm>
           <a:prstGeom prst="roundRect">
             <a:avLst>
@@ -5862,18 +3967,24 @@
       </p:sp>
       <p:sp>
         <p:nvSpPr>
-          <p:cNvPr id="9" name="Shape 7"/>
-          <p:cNvSpPr/>
-          <p:nvPr/>
-        </p:nvSpPr>
-        <p:spPr>
-          <a:xfrm>
-            <a:off x="411480" y="1481328"/>
-            <a:ext cx="3657600" cy="347472"/>
+          <p:cNvPr id="59" name="Shape 7">
+            <a:extLst>
+              <a:ext uri="{FF2B5EF4-FFF2-40B4-BE49-F238E27FC236}">
+                <a16:creationId xmlns:a16="http://schemas.microsoft.com/office/drawing/2014/main" id="{7CB32271-FF30-6AF0-6449-69D01C7CCAE8}"/>
+              </a:ext>
+            </a:extLst>
+          </p:cNvPr>
+          <p:cNvSpPr/>
+          <p:nvPr/>
+        </p:nvSpPr>
+        <p:spPr>
+          <a:xfrm>
+            <a:off x="2654096" y="3057144"/>
+            <a:ext cx="4114800" cy="347472"/>
           </a:xfrm>
           <a:prstGeom prst="roundRect">
             <a:avLst>
-              <a:gd name="adj" fmla="val 26316"/>
+              <a:gd name="adj" fmla="val 17179"/>
             </a:avLst>
           </a:prstGeom>
           <a:solidFill>
@@ -5889,14 +4000,20 @@
       </p:sp>
       <p:sp>
         <p:nvSpPr>
-          <p:cNvPr id="10" name="Text 8"/>
-          <p:cNvSpPr/>
-          <p:nvPr/>
-        </p:nvSpPr>
-        <p:spPr>
-          <a:xfrm>
-            <a:off x="548640" y="1481328"/>
-            <a:ext cx="3474720" cy="347472"/>
+          <p:cNvPr id="61" name="Text 8">
+            <a:extLst>
+              <a:ext uri="{FF2B5EF4-FFF2-40B4-BE49-F238E27FC236}">
+                <a16:creationId xmlns:a16="http://schemas.microsoft.com/office/drawing/2014/main" id="{9CFADEDF-D2A4-7F28-BE56-C813DB4E057B}"/>
+              </a:ext>
+            </a:extLst>
+          </p:cNvPr>
+          <p:cNvSpPr/>
+          <p:nvPr/>
+        </p:nvSpPr>
+        <p:spPr>
+          <a:xfrm>
+            <a:off x="2791256" y="3057144"/>
+            <a:ext cx="3909060" cy="347472"/>
           </a:xfrm>
           <a:prstGeom prst="rect">
             <a:avLst/>
@@ -5925,14 +4042,20 @@
       </p:sp>
       <p:sp>
         <p:nvSpPr>
-          <p:cNvPr id="11" name="Text 9"/>
-          <p:cNvSpPr/>
-          <p:nvPr/>
-        </p:nvSpPr>
-        <p:spPr>
-          <a:xfrm>
-            <a:off x="640080" y="1901952"/>
-            <a:ext cx="3291840" cy="2706624"/>
+          <p:cNvPr id="63" name="Text 9">
+            <a:extLst>
+              <a:ext uri="{FF2B5EF4-FFF2-40B4-BE49-F238E27FC236}">
+                <a16:creationId xmlns:a16="http://schemas.microsoft.com/office/drawing/2014/main" id="{123483A5-EDAB-DE28-5F63-4D149F3FA688}"/>
+              </a:ext>
+            </a:extLst>
+          </p:cNvPr>
+          <p:cNvSpPr/>
+          <p:nvPr/>
+        </p:nvSpPr>
+        <p:spPr>
+          <a:xfrm>
+            <a:off x="2882696" y="3458718"/>
+            <a:ext cx="3703320" cy="2706624"/>
           </a:xfrm>
           <a:prstGeom prst="rect">
             <a:avLst/>
@@ -5948,7 +4071,7 @@
               <a:buNone/>
             </a:pPr>
             <a:r>
-              <a:rPr lang="en-US" sz="1350" dirty="0">
+              <a:rPr lang="en-US" sz="1200" dirty="0">
                 <a:solidFill>
                   <a:srgbClr val="7EFFD3"/>
                 </a:solidFill>
@@ -5958,14 +4081,14 @@
               </a:rPr>
               <a:t>hasil_prediksi/</a:t>
             </a:r>
-            <a:endParaRPr lang="en-US" sz="1350" dirty="0"/>
+            <a:endParaRPr lang="en-US" sz="1200" dirty="0"/>
           </a:p>
           <a:p>
             <a:pPr marL="0" indent="0">
               <a:buNone/>
             </a:pPr>
             <a:r>
-              <a:rPr lang="en-US" sz="1350" dirty="0">
+              <a:rPr lang="en-US" sz="1200" dirty="0">
                 <a:solidFill>
                   <a:srgbClr val="7EFFD3"/>
                 </a:solidFill>
@@ -5973,16 +4096,10 @@
                 <a:ea typeface="Courier New" pitchFamily="34" charset="-122"/>
                 <a:cs typeface="Courier New" pitchFamily="34" charset="-120"/>
               </a:rPr>
-              <a:t>  IR42/</a:t>
-            </a:r>
-            <a:endParaRPr lang="en-US" sz="1350" dirty="0"/>
-          </a:p>
-          <a:p>
-            <a:pPr marL="0" indent="0">
-              <a:buNone/>
-            </a:pPr>
-            <a:r>
-              <a:rPr lang="en-US" sz="1350" dirty="0">
+              <a:t>  </a:t>
+            </a:r>
+            <a:r>
+              <a:rPr lang="en-US" sz="1200" dirty="0" err="1">
                 <a:solidFill>
                   <a:srgbClr val="7EFFD3"/>
                 </a:solidFill>
@@ -5990,16 +4107,10 @@
                 <a:ea typeface="Courier New" pitchFamily="34" charset="-122"/>
                 <a:cs typeface="Courier New" pitchFamily="34" charset="-120"/>
               </a:rPr>
-              <a:t>  Pandan/</a:t>
-            </a:r>
-            <a:endParaRPr lang="en-US" sz="1350" dirty="0"/>
-          </a:p>
-          <a:p>
-            <a:pPr marL="0" indent="0">
-              <a:buNone/>
-            </a:pPr>
-            <a:r>
-              <a:rPr lang="en-US" sz="1350" dirty="0">
+              <a:t>Beras_Gundukan</a:t>
+            </a:r>
+            <a:r>
+              <a:rPr lang="en-US" sz="1200" dirty="0">
                 <a:solidFill>
                   <a:srgbClr val="7EFFD3"/>
                 </a:solidFill>
@@ -6007,16 +4118,15 @@
                 <a:ea typeface="Courier New" pitchFamily="34" charset="-122"/>
                 <a:cs typeface="Courier New" pitchFamily="34" charset="-120"/>
               </a:rPr>
-              <a:t>  Ketan/</a:t>
-            </a:r>
-            <a:endParaRPr lang="en-US" sz="1350" dirty="0"/>
+              <a:t>/</a:t>
+            </a:r>
           </a:p>
           <a:p>
             <a:pPr marL="0" indent="0">
               <a:buNone/>
             </a:pPr>
             <a:r>
-              <a:rPr lang="en-US" sz="1350" dirty="0">
+              <a:rPr lang="en-US" sz="1200" dirty="0">
                 <a:solidFill>
                   <a:srgbClr val="7EFFD3"/>
                 </a:solidFill>
@@ -6024,16 +4134,10 @@
                 <a:ea typeface="Courier New" pitchFamily="34" charset="-122"/>
                 <a:cs typeface="Courier New" pitchFamily="34" charset="-120"/>
               </a:rPr>
-              <a:t>  Beras_Patahan/</a:t>
-            </a:r>
-            <a:endParaRPr lang="en-US" sz="1350" dirty="0"/>
-          </a:p>
-          <a:p>
-            <a:pPr marL="0" indent="0">
-              <a:buNone/>
-            </a:pPr>
-            <a:r>
-              <a:rPr lang="en-US" sz="1350" dirty="0">
+              <a:t>  </a:t>
+            </a:r>
+            <a:r>
+              <a:rPr lang="en-US" sz="1200" dirty="0" err="1">
                 <a:solidFill>
                   <a:srgbClr val="7EFFD3"/>
                 </a:solidFill>
@@ -6041,378 +4145,123 @@
                 <a:ea typeface="Courier New" pitchFamily="34" charset="-122"/>
                 <a:cs typeface="Courier New" pitchFamily="34" charset="-120"/>
               </a:rPr>
-              <a:t>  Tidak_Terdeteksi/</a:t>
-            </a:r>
-            <a:endParaRPr lang="en-US" sz="1350" dirty="0"/>
-          </a:p>
-        </p:txBody>
-      </p:sp>
-      <p:sp>
-        <p:nvSpPr>
-          <p:cNvPr id="12" name="Text 10"/>
-          <p:cNvSpPr/>
-          <p:nvPr/>
-        </p:nvSpPr>
-        <p:spPr>
-          <a:xfrm>
-            <a:off x="4480560" y="1481328"/>
-            <a:ext cx="4251960" cy="347472"/>
-          </a:xfrm>
-          <a:prstGeom prst="rect">
-            <a:avLst/>
-          </a:prstGeom>
-          <a:noFill/>
-          <a:ln/>
-        </p:spPr>
-        <p:txBody>
-          <a:bodyPr wrap="square" rtlCol="0" anchor="ctr"/>
-          <a:lstStyle/>
-          <a:p>
-            <a:pPr marL="0" indent="0" algn="ctr">
-              <a:buNone/>
-            </a:pPr>
-            <a:r>
-              <a:rPr lang="en-US" sz="1300" b="1" dirty="0">
-                <a:solidFill>
-                  <a:srgbClr val="1A6B4A"/>
-                </a:solidFill>
-                <a:latin typeface="Calibri" pitchFamily="34" charset="0"/>
-                <a:ea typeface="Calibri" pitchFamily="34" charset="-122"/>
-                <a:cs typeface="Calibri" pitchFamily="34" charset="-120"/>
-              </a:rPr>
-              <a:t>Folder per Kelas</a:t>
-            </a:r>
-            <a:endParaRPr lang="en-US" sz="1300" dirty="0"/>
-          </a:p>
-        </p:txBody>
-      </p:sp>
-      <p:sp>
-        <p:nvSpPr>
-          <p:cNvPr id="13" name="Shape 11"/>
-          <p:cNvSpPr/>
-          <p:nvPr/>
-        </p:nvSpPr>
-        <p:spPr>
-          <a:xfrm>
-            <a:off x="4480560" y="1920240"/>
-            <a:ext cx="4251960" cy="475488"/>
-          </a:xfrm>
-          <a:prstGeom prst="roundRect">
-            <a:avLst>
-              <a:gd name="adj" fmla="val 13462"/>
-            </a:avLst>
-          </a:prstGeom>
-          <a:solidFill>
-            <a:srgbClr val="F4FAF7"/>
-          </a:solidFill>
-          <a:ln w="6350">
-            <a:solidFill>
-              <a:srgbClr val="D0E8DC"/>
-            </a:solidFill>
-            <a:prstDash val="solid"/>
-          </a:ln>
-        </p:spPr>
-      </p:sp>
-      <p:sp>
-        <p:nvSpPr>
-          <p:cNvPr id="14" name="Text 12"/>
-          <p:cNvSpPr/>
-          <p:nvPr/>
-        </p:nvSpPr>
-        <p:spPr>
-          <a:xfrm>
-            <a:off x="4663440" y="1920240"/>
-            <a:ext cx="3840480" cy="475488"/>
-          </a:xfrm>
-          <a:prstGeom prst="rect">
-            <a:avLst/>
-          </a:prstGeom>
-          <a:noFill/>
-          <a:ln/>
-        </p:spPr>
-        <p:txBody>
-          <a:bodyPr wrap="square" rtlCol="0" anchor="ctr"/>
-          <a:lstStyle/>
-          <a:p>
-            <a:pPr marL="0" indent="0">
-              <a:buNone/>
-            </a:pPr>
-            <a:r>
-              <a:rPr lang="en-US" sz="1300" dirty="0">
-                <a:solidFill>
-                  <a:srgbClr val="1A6B4A"/>
+              <a:t>Beras_Patahan</a:t>
+            </a:r>
+            <a:r>
+              <a:rPr lang="en-US" sz="1200" dirty="0">
+                <a:solidFill>
+                  <a:srgbClr val="7EFFD3"/>
                 </a:solidFill>
                 <a:latin typeface="Courier New" pitchFamily="34" charset="0"/>
                 <a:ea typeface="Courier New" pitchFamily="34" charset="-122"/>
                 <a:cs typeface="Courier New" pitchFamily="34" charset="-120"/>
               </a:rPr>
-              <a:t>📁 IR42/</a:t>
-            </a:r>
-            <a:endParaRPr lang="en-US" sz="1300" dirty="0"/>
-          </a:p>
-        </p:txBody>
-      </p:sp>
-      <p:sp>
-        <p:nvSpPr>
-          <p:cNvPr id="15" name="Shape 13"/>
-          <p:cNvSpPr/>
-          <p:nvPr/>
-        </p:nvSpPr>
-        <p:spPr>
-          <a:xfrm>
-            <a:off x="4480560" y="2523744"/>
-            <a:ext cx="4251960" cy="475488"/>
-          </a:xfrm>
-          <a:prstGeom prst="roundRect">
-            <a:avLst>
-              <a:gd name="adj" fmla="val 13462"/>
-            </a:avLst>
-          </a:prstGeom>
-          <a:solidFill>
-            <a:srgbClr val="F4FAF7"/>
-          </a:solidFill>
-          <a:ln w="6350">
-            <a:solidFill>
-              <a:srgbClr val="D0E8DC"/>
-            </a:solidFill>
-            <a:prstDash val="solid"/>
-          </a:ln>
-        </p:spPr>
-      </p:sp>
-      <p:sp>
-        <p:nvSpPr>
-          <p:cNvPr id="16" name="Text 14"/>
-          <p:cNvSpPr/>
-          <p:nvPr/>
-        </p:nvSpPr>
-        <p:spPr>
-          <a:xfrm>
-            <a:off x="4663440" y="2523744"/>
-            <a:ext cx="3840480" cy="475488"/>
-          </a:xfrm>
-          <a:prstGeom prst="rect">
-            <a:avLst/>
-          </a:prstGeom>
-          <a:noFill/>
-          <a:ln/>
-        </p:spPr>
-        <p:txBody>
-          <a:bodyPr wrap="square" rtlCol="0" anchor="ctr"/>
-          <a:lstStyle/>
+              <a:t>/</a:t>
+            </a:r>
+          </a:p>
           <a:p>
             <a:pPr marL="0" indent="0">
               <a:buNone/>
             </a:pPr>
             <a:r>
-              <a:rPr lang="en-US" sz="1300" dirty="0">
-                <a:solidFill>
-                  <a:srgbClr val="1A6B4A"/>
+              <a:rPr lang="en-US" sz="1200" dirty="0">
+                <a:solidFill>
+                  <a:srgbClr val="7EFFD3"/>
                 </a:solidFill>
                 <a:latin typeface="Courier New" pitchFamily="34" charset="0"/>
                 <a:ea typeface="Courier New" pitchFamily="34" charset="-122"/>
                 <a:cs typeface="Courier New" pitchFamily="34" charset="-120"/>
               </a:rPr>
-              <a:t>📁 Pandan/</a:t>
-            </a:r>
-            <a:endParaRPr lang="en-US" sz="1300" dirty="0"/>
-          </a:p>
-        </p:txBody>
-      </p:sp>
-      <p:sp>
-        <p:nvSpPr>
-          <p:cNvPr id="17" name="Shape 15"/>
-          <p:cNvSpPr/>
-          <p:nvPr/>
-        </p:nvSpPr>
-        <p:spPr>
-          <a:xfrm>
-            <a:off x="4480560" y="3127248"/>
-            <a:ext cx="4251960" cy="475488"/>
-          </a:xfrm>
-          <a:prstGeom prst="roundRect">
-            <a:avLst>
-              <a:gd name="adj" fmla="val 13462"/>
-            </a:avLst>
-          </a:prstGeom>
-          <a:solidFill>
-            <a:srgbClr val="F4FAF7"/>
-          </a:solidFill>
-          <a:ln w="6350">
-            <a:solidFill>
-              <a:srgbClr val="D0E8DC"/>
-            </a:solidFill>
-            <a:prstDash val="solid"/>
-          </a:ln>
-        </p:spPr>
-      </p:sp>
-      <p:sp>
-        <p:nvSpPr>
-          <p:cNvPr id="18" name="Text 16"/>
-          <p:cNvSpPr/>
-          <p:nvPr/>
-        </p:nvSpPr>
-        <p:spPr>
-          <a:xfrm>
-            <a:off x="4663440" y="3127248"/>
-            <a:ext cx="3840480" cy="475488"/>
-          </a:xfrm>
-          <a:prstGeom prst="rect">
-            <a:avLst/>
-          </a:prstGeom>
-          <a:noFill/>
-          <a:ln/>
-        </p:spPr>
-        <p:txBody>
-          <a:bodyPr wrap="square" rtlCol="0" anchor="ctr"/>
-          <a:lstStyle/>
-          <a:p>
-            <a:pPr marL="0" indent="0">
-              <a:buNone/>
-            </a:pPr>
-            <a:r>
-              <a:rPr lang="en-US" sz="1300" dirty="0">
-                <a:solidFill>
-                  <a:srgbClr val="1A6B4A"/>
+              <a:t>  </a:t>
+            </a:r>
+            <a:r>
+              <a:rPr lang="en-US" sz="1200" dirty="0" err="1">
+                <a:solidFill>
+                  <a:srgbClr val="7EFFD3"/>
                 </a:solidFill>
                 <a:latin typeface="Courier New" pitchFamily="34" charset="0"/>
                 <a:ea typeface="Courier New" pitchFamily="34" charset="-122"/>
                 <a:cs typeface="Courier New" pitchFamily="34" charset="-120"/>
               </a:rPr>
-              <a:t>📁 Ketan/</a:t>
-            </a:r>
-            <a:endParaRPr lang="en-US" sz="1300" dirty="0"/>
-          </a:p>
-        </p:txBody>
-      </p:sp>
-      <p:sp>
-        <p:nvSpPr>
-          <p:cNvPr id="19" name="Shape 17"/>
-          <p:cNvSpPr/>
-          <p:nvPr/>
-        </p:nvSpPr>
-        <p:spPr>
-          <a:xfrm>
-            <a:off x="4480560" y="3730752"/>
-            <a:ext cx="4251960" cy="475488"/>
-          </a:xfrm>
-          <a:prstGeom prst="roundRect">
-            <a:avLst>
-              <a:gd name="adj" fmla="val 13462"/>
-            </a:avLst>
-          </a:prstGeom>
-          <a:solidFill>
-            <a:srgbClr val="F4FAF7"/>
-          </a:solidFill>
-          <a:ln w="6350">
-            <a:solidFill>
-              <a:srgbClr val="D0E8DC"/>
-            </a:solidFill>
-            <a:prstDash val="solid"/>
-          </a:ln>
-        </p:spPr>
-      </p:sp>
-      <p:sp>
-        <p:nvSpPr>
-          <p:cNvPr id="20" name="Text 18"/>
-          <p:cNvSpPr/>
-          <p:nvPr/>
-        </p:nvSpPr>
-        <p:spPr>
-          <a:xfrm>
-            <a:off x="4663440" y="3730752"/>
-            <a:ext cx="3840480" cy="475488"/>
-          </a:xfrm>
-          <a:prstGeom prst="rect">
-            <a:avLst/>
-          </a:prstGeom>
-          <a:noFill/>
-          <a:ln/>
-        </p:spPr>
-        <p:txBody>
-          <a:bodyPr wrap="square" rtlCol="0" anchor="ctr"/>
-          <a:lstStyle/>
-          <a:p>
-            <a:pPr marL="0" indent="0">
-              <a:buNone/>
-            </a:pPr>
-            <a:r>
-              <a:rPr lang="en-US" sz="1300" dirty="0">
-                <a:solidFill>
-                  <a:srgbClr val="1A6B4A"/>
+              <a:t>Beras_Utuh</a:t>
+            </a:r>
+            <a:r>
+              <a:rPr lang="en-US" sz="1200" dirty="0">
+                <a:solidFill>
+                  <a:srgbClr val="7EFFD3"/>
                 </a:solidFill>
                 <a:latin typeface="Courier New" pitchFamily="34" charset="0"/>
                 <a:ea typeface="Courier New" pitchFamily="34" charset="-122"/>
                 <a:cs typeface="Courier New" pitchFamily="34" charset="-120"/>
               </a:rPr>
-              <a:t>📁 Beras_Patahan/</a:t>
-            </a:r>
-            <a:endParaRPr lang="en-US" sz="1300" dirty="0"/>
-          </a:p>
-        </p:txBody>
-      </p:sp>
-      <p:sp>
-        <p:nvSpPr>
-          <p:cNvPr id="21" name="Shape 19"/>
-          <p:cNvSpPr/>
-          <p:nvPr/>
-        </p:nvSpPr>
-        <p:spPr>
-          <a:xfrm>
-            <a:off x="4480560" y="4334256"/>
-            <a:ext cx="4251960" cy="475488"/>
-          </a:xfrm>
-          <a:prstGeom prst="roundRect">
-            <a:avLst>
-              <a:gd name="adj" fmla="val 13462"/>
-            </a:avLst>
-          </a:prstGeom>
-          <a:solidFill>
-            <a:srgbClr val="FFF5E6"/>
-          </a:solidFill>
-          <a:ln w="6350">
-            <a:solidFill>
-              <a:srgbClr val="F0A500"/>
-            </a:solidFill>
-            <a:prstDash val="solid"/>
-          </a:ln>
-        </p:spPr>
-      </p:sp>
-      <p:sp>
-        <p:nvSpPr>
-          <p:cNvPr id="22" name="Text 20"/>
-          <p:cNvSpPr/>
-          <p:nvPr/>
-        </p:nvSpPr>
-        <p:spPr>
-          <a:xfrm>
-            <a:off x="4663440" y="4334256"/>
-            <a:ext cx="3840480" cy="475488"/>
-          </a:xfrm>
-          <a:prstGeom prst="rect">
-            <a:avLst/>
-          </a:prstGeom>
-          <a:noFill/>
-          <a:ln/>
-        </p:spPr>
-        <p:txBody>
-          <a:bodyPr wrap="square" rtlCol="0" anchor="ctr"/>
-          <a:lstStyle/>
+              <a:t>/</a:t>
+            </a:r>
+          </a:p>
           <a:p>
             <a:pPr marL="0" indent="0">
               <a:buNone/>
             </a:pPr>
             <a:r>
-              <a:rPr lang="en-US" sz="1300" b="1" dirty="0">
-                <a:solidFill>
-                  <a:srgbClr val="F0A500"/>
+              <a:rPr lang="en-US" sz="1200" dirty="0">
+                <a:solidFill>
+                  <a:srgbClr val="7EFFD3"/>
                 </a:solidFill>
                 <a:latin typeface="Courier New" pitchFamily="34" charset="0"/>
                 <a:ea typeface="Courier New" pitchFamily="34" charset="-122"/>
                 <a:cs typeface="Courier New" pitchFamily="34" charset="-120"/>
               </a:rPr>
-              <a:t>⚠️ Tidak_Terdeteksi/</a:t>
-            </a:r>
-            <a:endParaRPr lang="en-US" sz="1300" dirty="0"/>
+              <a:t>  IR42/</a:t>
+            </a:r>
+          </a:p>
+          <a:p>
+            <a:pPr marL="0" indent="0">
+              <a:buNone/>
+            </a:pPr>
+            <a:r>
+              <a:rPr lang="en-US" sz="1200" dirty="0">
+                <a:solidFill>
+                  <a:srgbClr val="7EFFD3"/>
+                </a:solidFill>
+                <a:latin typeface="Courier New" pitchFamily="34" charset="0"/>
+                <a:cs typeface="Courier New" pitchFamily="34" charset="-120"/>
+              </a:rPr>
+              <a:t>  IR64</a:t>
+            </a:r>
+            <a:endParaRPr lang="en-US" sz="1200" dirty="0"/>
+          </a:p>
+          <a:p>
+            <a:pPr marL="0" indent="0">
+              <a:buNone/>
+            </a:pPr>
+            <a:r>
+              <a:rPr lang="en-US" sz="1200" dirty="0">
+                <a:solidFill>
+                  <a:srgbClr val="7EFFD3"/>
+                </a:solidFill>
+                <a:latin typeface="Courier New" pitchFamily="34" charset="0"/>
+                <a:ea typeface="Courier New" pitchFamily="34" charset="-122"/>
+                <a:cs typeface="Courier New" pitchFamily="34" charset="-120"/>
+              </a:rPr>
+              <a:t>  Ketan/</a:t>
+            </a:r>
+            <a:endParaRPr lang="en-US" sz="1200" dirty="0"/>
+          </a:p>
+          <a:p>
+            <a:pPr marL="0" indent="0">
+              <a:buNone/>
+            </a:pPr>
+            <a:r>
+              <a:rPr lang="en-US" sz="1200" dirty="0">
+                <a:solidFill>
+                  <a:srgbClr val="7EFFD3"/>
+                </a:solidFill>
+                <a:latin typeface="Courier New" pitchFamily="34" charset="0"/>
+                <a:ea typeface="Courier New" pitchFamily="34" charset="-122"/>
+                <a:cs typeface="Courier New" pitchFamily="34" charset="-120"/>
+              </a:rPr>
+              <a:t>  Pandan/</a:t>
+            </a:r>
+            <a:endParaRPr lang="en-US" sz="1200" dirty="0"/>
           </a:p>
         </p:txBody>
       </p:sp>
@@ -6424,7 +4273,7 @@
 </p:sld>
 </file>
 
-<file path=ppt/slides/slide15.xml><?xml version="1.0" encoding="utf-8"?>
+<file path=ppt/slides/slide12.xml><?xml version="1.0" encoding="utf-8"?>
 <p:sld xmlns:a="http://schemas.openxmlformats.org/drawingml/2006/main" xmlns:r="http://schemas.openxmlformats.org/officeDocument/2006/relationships" xmlns:p="http://schemas.openxmlformats.org/presentationml/2006/main">
   <p:cSld name="Slide 15">
     <p:bg>
@@ -6451,141 +4300,20 @@
       </p:grpSpPr>
       <p:sp>
         <p:nvSpPr>
-          <p:cNvPr id="2" name="Shape 0"/>
-          <p:cNvSpPr/>
-          <p:nvPr/>
-        </p:nvSpPr>
-        <p:spPr>
-          <a:xfrm>
-            <a:off x="0" y="0"/>
-            <a:ext cx="9144000" cy="914400"/>
-          </a:xfrm>
-          <a:prstGeom prst="rect">
-            <a:avLst/>
-          </a:prstGeom>
-          <a:solidFill>
-            <a:srgbClr val="0D3B2E"/>
-          </a:solidFill>
-          <a:ln w="12700">
-            <a:solidFill>
-              <a:srgbClr val="0D3B2E"/>
-            </a:solidFill>
-            <a:prstDash val="solid"/>
-          </a:ln>
-        </p:spPr>
-      </p:sp>
-      <p:sp>
-        <p:nvSpPr>
-          <p:cNvPr id="3" name="Shape 1"/>
-          <p:cNvSpPr/>
-          <p:nvPr/>
-        </p:nvSpPr>
-        <p:spPr>
-          <a:xfrm>
-            <a:off x="320040" y="137160"/>
-            <a:ext cx="457200" cy="457200"/>
-          </a:xfrm>
-          <a:prstGeom prst="roundRect">
-            <a:avLst>
-              <a:gd name="adj" fmla="val 12000"/>
-            </a:avLst>
-          </a:prstGeom>
-          <a:solidFill>
-            <a:srgbClr val="2ECC8F"/>
-          </a:solidFill>
-          <a:ln w="12700">
-            <a:solidFill>
-              <a:srgbClr val="2ECC8F"/>
-            </a:solidFill>
-            <a:prstDash val="solid"/>
-          </a:ln>
-        </p:spPr>
-      </p:sp>
-      <p:sp>
-        <p:nvSpPr>
-          <p:cNvPr id="4" name="Text 2"/>
-          <p:cNvSpPr/>
-          <p:nvPr/>
-        </p:nvSpPr>
-        <p:spPr>
-          <a:xfrm>
-            <a:off x="320040" y="137160"/>
-            <a:ext cx="457200" cy="457200"/>
-          </a:xfrm>
-          <a:prstGeom prst="rect">
-            <a:avLst/>
-          </a:prstGeom>
-          <a:noFill/>
-          <a:ln/>
-        </p:spPr>
-        <p:txBody>
-          <a:bodyPr wrap="square" lIns="0" tIns="0" rIns="0" bIns="0" rtlCol="0" anchor="ctr"/>
-          <a:lstStyle/>
-          <a:p>
-            <a:pPr marL="0" indent="0" algn="ctr">
-              <a:buNone/>
-            </a:pPr>
-            <a:r>
-              <a:rPr lang="en-US" sz="1300" b="1" dirty="0">
-                <a:solidFill>
-                  <a:srgbClr val="0D3B2E"/>
-                </a:solidFill>
-              </a:rPr>
-              <a:t>15</a:t>
-            </a:r>
-            <a:endParaRPr lang="en-US" sz="1300" dirty="0"/>
-          </a:p>
-        </p:txBody>
-      </p:sp>
-      <p:sp>
-        <p:nvSpPr>
-          <p:cNvPr id="5" name="Text 3"/>
-          <p:cNvSpPr/>
-          <p:nvPr/>
-        </p:nvSpPr>
-        <p:spPr>
-          <a:xfrm>
-            <a:off x="914400" y="109728"/>
-            <a:ext cx="7955280" cy="694944"/>
-          </a:xfrm>
-          <a:prstGeom prst="rect">
-            <a:avLst/>
-          </a:prstGeom>
-          <a:noFill/>
-          <a:ln/>
-        </p:spPr>
-        <p:txBody>
-          <a:bodyPr wrap="square" rtlCol="0" anchor="ctr"/>
-          <a:lstStyle/>
-          <a:p>
-            <a:pPr marL="0" indent="0">
-              <a:buNone/>
-            </a:pPr>
-            <a:r>
-              <a:rPr lang="en-US" sz="2200" b="1" dirty="0">
-                <a:solidFill>
-                  <a:srgbClr val="FFFFFF"/>
-                </a:solidFill>
-                <a:latin typeface="Cambria" pitchFamily="34" charset="0"/>
-                <a:ea typeface="Cambria" pitchFamily="34" charset="-122"/>
-                <a:cs typeface="Cambria" pitchFamily="34" charset="-120"/>
-              </a:rPr>
-              <a:t>Alur Demo</a:t>
-            </a:r>
-            <a:endParaRPr lang="en-US" sz="2200" dirty="0"/>
-          </a:p>
-        </p:txBody>
-      </p:sp>
-      <p:sp>
-        <p:nvSpPr>
-          <p:cNvPr id="6" name="Shape 4"/>
-          <p:cNvSpPr/>
-          <p:nvPr/>
-        </p:nvSpPr>
-        <p:spPr>
-          <a:xfrm>
-            <a:off x="7863840" y="-274320"/>
-            <a:ext cx="1463040" cy="1463040"/>
+          <p:cNvPr id="32" name="Shape 4">
+            <a:extLst>
+              <a:ext uri="{FF2B5EF4-FFF2-40B4-BE49-F238E27FC236}">
+                <a16:creationId xmlns:a16="http://schemas.microsoft.com/office/drawing/2014/main" id="{3306BF0E-D07D-1BCE-00A2-966AF0E4E4DF}"/>
+              </a:ext>
+            </a:extLst>
+          </p:cNvPr>
+          <p:cNvSpPr/>
+          <p:nvPr/>
+        </p:nvSpPr>
+        <p:spPr>
+          <a:xfrm>
+            <a:off x="-202237" y="3530785"/>
+            <a:ext cx="2658435" cy="2414598"/>
           </a:xfrm>
           <a:prstGeom prst="ellipse">
             <a:avLst/>
@@ -6607,14 +4335,71 @@
       </p:sp>
       <p:sp>
         <p:nvSpPr>
-          <p:cNvPr id="7" name="Shape 5"/>
-          <p:cNvSpPr/>
-          <p:nvPr/>
-        </p:nvSpPr>
-        <p:spPr>
-          <a:xfrm>
-            <a:off x="411480" y="1078992"/>
-            <a:ext cx="4069080" cy="1143000"/>
+          <p:cNvPr id="5" name="Text 3"/>
+          <p:cNvSpPr/>
+          <p:nvPr/>
+        </p:nvSpPr>
+        <p:spPr>
+          <a:xfrm>
+            <a:off x="914400" y="109728"/>
+            <a:ext cx="7955280" cy="694944"/>
+          </a:xfrm>
+          <a:prstGeom prst="rect">
+            <a:avLst/>
+          </a:prstGeom>
+          <a:noFill/>
+          <a:ln/>
+        </p:spPr>
+        <p:txBody>
+          <a:bodyPr wrap="square" rtlCol="0" anchor="ctr"/>
+          <a:lstStyle/>
+          <a:p>
+            <a:pPr marL="0" indent="0">
+              <a:buNone/>
+            </a:pPr>
+            <a:endParaRPr lang="en-US" sz="2200" dirty="0"/>
+          </a:p>
+        </p:txBody>
+      </p:sp>
+      <p:sp>
+        <p:nvSpPr>
+          <p:cNvPr id="6" name="Shape 4"/>
+          <p:cNvSpPr/>
+          <p:nvPr/>
+        </p:nvSpPr>
+        <p:spPr>
+          <a:xfrm>
+            <a:off x="7863840" y="-274320"/>
+            <a:ext cx="1463040" cy="1463040"/>
+          </a:xfrm>
+          <a:prstGeom prst="ellipse">
+            <a:avLst/>
+          </a:prstGeom>
+          <a:solidFill>
+            <a:srgbClr val="2ECC8F">
+              <a:alpha val="20000"/>
+            </a:srgbClr>
+          </a:solidFill>
+          <a:ln w="12700">
+            <a:solidFill>
+              <a:srgbClr val="2ECC8F">
+                <a:alpha val="20000"/>
+              </a:srgbClr>
+            </a:solidFill>
+            <a:prstDash val="solid"/>
+          </a:ln>
+        </p:spPr>
+      </p:sp>
+      <p:sp>
+        <p:nvSpPr>
+          <p:cNvPr id="19" name="Shape 17"/>
+          <p:cNvSpPr/>
+          <p:nvPr/>
+        </p:nvSpPr>
+        <p:spPr>
+          <a:xfrm>
+            <a:off x="992777" y="960120"/>
+            <a:ext cx="7158446" cy="3223260"/>
           </a:xfrm>
           <a:prstGeom prst="roundRect">
             <a:avLst>
@@ -6641,40 +4426,15 @@
       </p:sp>
       <p:sp>
         <p:nvSpPr>
-          <p:cNvPr id="8" name="Shape 6"/>
-          <p:cNvSpPr/>
-          <p:nvPr/>
-        </p:nvSpPr>
-        <p:spPr>
-          <a:xfrm>
-            <a:off x="548640" y="1371600"/>
+          <p:cNvPr id="21" name="Text 19"/>
+          <p:cNvSpPr/>
+          <p:nvPr/>
+        </p:nvSpPr>
+        <p:spPr>
+          <a:xfrm>
+            <a:off x="4937760" y="1371600"/>
             <a:ext cx="548640" cy="548640"/>
           </a:xfrm>
-          <a:prstGeom prst="ellipse">
-            <a:avLst/>
-          </a:prstGeom>
-          <a:solidFill>
-            <a:srgbClr val="1A6B4A"/>
-          </a:solidFill>
-          <a:ln w="12700">
-            <a:solidFill>
-              <a:srgbClr val="1A6B4A"/>
-            </a:solidFill>
-            <a:prstDash val="solid"/>
-          </a:ln>
-        </p:spPr>
-      </p:sp>
-      <p:sp>
-        <p:nvSpPr>
-          <p:cNvPr id="9" name="Text 7"/>
-          <p:cNvSpPr/>
-          <p:nvPr/>
-        </p:nvSpPr>
-        <p:spPr>
-          <a:xfrm>
-            <a:off x="548640" y="1371600"/>
-            <a:ext cx="548640" cy="548640"/>
-          </a:xfrm>
           <a:prstGeom prst="rect">
             <a:avLst/>
           </a:prstGeom>
@@ -6694,7 +4454,7 @@
                   <a:srgbClr val="FFFFFF"/>
                 </a:solidFill>
               </a:rPr>
-              <a:t>1</a:t>
+              <a:t>4</a:t>
             </a:r>
             <a:endParaRPr lang="en-US" sz="1400" dirty="0"/>
           </a:p>
@@ -6702,14 +4462,14 @@
       </p:sp>
       <p:sp>
         <p:nvSpPr>
-          <p:cNvPr id="10" name="Text 8"/>
-          <p:cNvSpPr/>
-          <p:nvPr/>
-        </p:nvSpPr>
-        <p:spPr>
-          <a:xfrm>
-            <a:off x="1216152" y="1124712"/>
-            <a:ext cx="3127248" cy="1051560"/>
+          <p:cNvPr id="22" name="Text 20"/>
+          <p:cNvSpPr/>
+          <p:nvPr/>
+        </p:nvSpPr>
+        <p:spPr>
+          <a:xfrm>
+            <a:off x="1241448" y="1670563"/>
+            <a:ext cx="6661104" cy="1802374"/>
           </a:xfrm>
           <a:prstGeom prst="rect">
             <a:avLst/>
@@ -6721,11 +4481,11 @@
           <a:bodyPr wrap="square" rtlCol="0" anchor="ctr"/>
           <a:lstStyle/>
           <a:p>
-            <a:pPr marL="0" indent="0">
-              <a:buNone/>
-            </a:pPr>
-            <a:r>
-              <a:rPr lang="en-US" sz="1250" dirty="0">
+            <a:pPr marL="0" indent="0" algn="ctr">
+              <a:buNone/>
+            </a:pPr>
+            <a:r>
+              <a:rPr lang="en-US" sz="6600" dirty="0">
                 <a:solidFill>
                   <a:srgbClr val="1E2D27"/>
                 </a:solidFill>
@@ -6733,679 +4493,9 @@
                 <a:ea typeface="Calibri" pitchFamily="34" charset="-122"/>
                 <a:cs typeface="Calibri" pitchFamily="34" charset="-120"/>
               </a:rPr>
-              <a:t>Buka terminal di folder Project</a:t>
-            </a:r>
-            <a:endParaRPr lang="en-US" sz="1250" dirty="0"/>
-          </a:p>
-        </p:txBody>
-      </p:sp>
-      <p:sp>
-        <p:nvSpPr>
-          <p:cNvPr id="11" name="Shape 9"/>
-          <p:cNvSpPr/>
-          <p:nvPr/>
-        </p:nvSpPr>
-        <p:spPr>
-          <a:xfrm>
-            <a:off x="411480" y="2377440"/>
-            <a:ext cx="4069080" cy="1143000"/>
-          </a:xfrm>
-          <a:prstGeom prst="roundRect">
-            <a:avLst>
-              <a:gd name="adj" fmla="val 8000"/>
-            </a:avLst>
-          </a:prstGeom>
-          <a:solidFill>
-            <a:srgbClr val="F4FAF7"/>
-          </a:solidFill>
-          <a:ln w="6350">
-            <a:solidFill>
-              <a:srgbClr val="D0E8DC"/>
-            </a:solidFill>
-            <a:prstDash val="solid"/>
-          </a:ln>
-          <a:effectLst>
-            <a:outerShdw blurRad="101600" dist="38100" dir="2700000" algn="bl" rotWithShape="0">
-              <a:srgbClr val="000000">
-                <a:alpha val="12000"/>
-              </a:srgbClr>
-            </a:outerShdw>
-          </a:effectLst>
-        </p:spPr>
-      </p:sp>
-      <p:sp>
-        <p:nvSpPr>
-          <p:cNvPr id="12" name="Shape 10"/>
-          <p:cNvSpPr/>
-          <p:nvPr/>
-        </p:nvSpPr>
-        <p:spPr>
-          <a:xfrm>
-            <a:off x="548640" y="2670048"/>
-            <a:ext cx="548640" cy="548640"/>
-          </a:xfrm>
-          <a:prstGeom prst="ellipse">
-            <a:avLst/>
-          </a:prstGeom>
-          <a:solidFill>
-            <a:srgbClr val="1A6B4A"/>
-          </a:solidFill>
-          <a:ln w="12700">
-            <a:solidFill>
-              <a:srgbClr val="1A6B4A"/>
-            </a:solidFill>
-            <a:prstDash val="solid"/>
-          </a:ln>
-        </p:spPr>
-      </p:sp>
-      <p:sp>
-        <p:nvSpPr>
-          <p:cNvPr id="13" name="Text 11"/>
-          <p:cNvSpPr/>
-          <p:nvPr/>
-        </p:nvSpPr>
-        <p:spPr>
-          <a:xfrm>
-            <a:off x="548640" y="2670048"/>
-            <a:ext cx="548640" cy="548640"/>
-          </a:xfrm>
-          <a:prstGeom prst="rect">
-            <a:avLst/>
-          </a:prstGeom>
-          <a:noFill/>
-          <a:ln/>
-        </p:spPr>
-        <p:txBody>
-          <a:bodyPr wrap="square" lIns="0" tIns="0" rIns="0" bIns="0" rtlCol="0" anchor="ctr"/>
-          <a:lstStyle/>
-          <a:p>
-            <a:pPr marL="0" indent="0" algn="ctr">
-              <a:buNone/>
-            </a:pPr>
-            <a:r>
-              <a:rPr lang="en-US" sz="1400" b="1" dirty="0">
-                <a:solidFill>
-                  <a:srgbClr val="FFFFFF"/>
-                </a:solidFill>
-              </a:rPr>
-              <a:t>2</a:t>
-            </a:r>
-            <a:endParaRPr lang="en-US" sz="1400" dirty="0"/>
-          </a:p>
-        </p:txBody>
-      </p:sp>
-      <p:sp>
-        <p:nvSpPr>
-          <p:cNvPr id="14" name="Text 12"/>
-          <p:cNvSpPr/>
-          <p:nvPr/>
-        </p:nvSpPr>
-        <p:spPr>
-          <a:xfrm>
-            <a:off x="1216152" y="2423160"/>
-            <a:ext cx="3127248" cy="1051560"/>
-          </a:xfrm>
-          <a:prstGeom prst="rect">
-            <a:avLst/>
-          </a:prstGeom>
-          <a:noFill/>
-          <a:ln/>
-        </p:spPr>
-        <p:txBody>
-          <a:bodyPr wrap="square" rtlCol="0" anchor="ctr"/>
-          <a:lstStyle/>
-          <a:p>
-            <a:pPr marL="0" indent="0">
-              <a:buNone/>
-            </a:pPr>
-            <a:r>
-              <a:rPr lang="en-US" sz="1250" dirty="0">
-                <a:solidFill>
-                  <a:srgbClr val="1E2D27"/>
-                </a:solidFill>
-                <a:latin typeface="Calibri" pitchFamily="34" charset="0"/>
-                <a:ea typeface="Calibri" pitchFamily="34" charset="-122"/>
-                <a:cs typeface="Calibri" pitchFamily="34" charset="-120"/>
-              </a:rPr>
-              <a:t>Jalankan: python gui_predict.py</a:t>
-            </a:r>
-            <a:endParaRPr lang="en-US" sz="1250" dirty="0"/>
-          </a:p>
-        </p:txBody>
-      </p:sp>
-      <p:sp>
-        <p:nvSpPr>
-          <p:cNvPr id="15" name="Shape 13"/>
-          <p:cNvSpPr/>
-          <p:nvPr/>
-        </p:nvSpPr>
-        <p:spPr>
-          <a:xfrm>
-            <a:off x="411480" y="3675888"/>
-            <a:ext cx="4069080" cy="1143000"/>
-          </a:xfrm>
-          <a:prstGeom prst="roundRect">
-            <a:avLst>
-              <a:gd name="adj" fmla="val 8000"/>
-            </a:avLst>
-          </a:prstGeom>
-          <a:solidFill>
-            <a:srgbClr val="F4FAF7"/>
-          </a:solidFill>
-          <a:ln w="6350">
-            <a:solidFill>
-              <a:srgbClr val="D0E8DC"/>
-            </a:solidFill>
-            <a:prstDash val="solid"/>
-          </a:ln>
-          <a:effectLst>
-            <a:outerShdw blurRad="101600" dist="38100" dir="2700000" algn="bl" rotWithShape="0">
-              <a:srgbClr val="000000">
-                <a:alpha val="12000"/>
-              </a:srgbClr>
-            </a:outerShdw>
-          </a:effectLst>
-        </p:spPr>
-      </p:sp>
-      <p:sp>
-        <p:nvSpPr>
-          <p:cNvPr id="16" name="Shape 14"/>
-          <p:cNvSpPr/>
-          <p:nvPr/>
-        </p:nvSpPr>
-        <p:spPr>
-          <a:xfrm>
-            <a:off x="548640" y="3968496"/>
-            <a:ext cx="548640" cy="548640"/>
-          </a:xfrm>
-          <a:prstGeom prst="ellipse">
-            <a:avLst/>
-          </a:prstGeom>
-          <a:solidFill>
-            <a:srgbClr val="1A6B4A"/>
-          </a:solidFill>
-          <a:ln w="12700">
-            <a:solidFill>
-              <a:srgbClr val="1A6B4A"/>
-            </a:solidFill>
-            <a:prstDash val="solid"/>
-          </a:ln>
-        </p:spPr>
-      </p:sp>
-      <p:sp>
-        <p:nvSpPr>
-          <p:cNvPr id="17" name="Text 15"/>
-          <p:cNvSpPr/>
-          <p:nvPr/>
-        </p:nvSpPr>
-        <p:spPr>
-          <a:xfrm>
-            <a:off x="548640" y="3968496"/>
-            <a:ext cx="548640" cy="548640"/>
-          </a:xfrm>
-          <a:prstGeom prst="rect">
-            <a:avLst/>
-          </a:prstGeom>
-          <a:noFill/>
-          <a:ln/>
-        </p:spPr>
-        <p:txBody>
-          <a:bodyPr wrap="square" lIns="0" tIns="0" rIns="0" bIns="0" rtlCol="0" anchor="ctr"/>
-          <a:lstStyle/>
-          <a:p>
-            <a:pPr marL="0" indent="0" algn="ctr">
-              <a:buNone/>
-            </a:pPr>
-            <a:r>
-              <a:rPr lang="en-US" sz="1400" b="1" dirty="0">
-                <a:solidFill>
-                  <a:srgbClr val="FFFFFF"/>
-                </a:solidFill>
-              </a:rPr>
-              <a:t>3</a:t>
-            </a:r>
-            <a:endParaRPr lang="en-US" sz="1400" dirty="0"/>
-          </a:p>
-        </p:txBody>
-      </p:sp>
-      <p:sp>
-        <p:nvSpPr>
-          <p:cNvPr id="18" name="Text 16"/>
-          <p:cNvSpPr/>
-          <p:nvPr/>
-        </p:nvSpPr>
-        <p:spPr>
-          <a:xfrm>
-            <a:off x="1216152" y="3721608"/>
-            <a:ext cx="3127248" cy="1051560"/>
-          </a:xfrm>
-          <a:prstGeom prst="rect">
-            <a:avLst/>
-          </a:prstGeom>
-          <a:noFill/>
-          <a:ln/>
-        </p:spPr>
-        <p:txBody>
-          <a:bodyPr wrap="square" rtlCol="0" anchor="ctr"/>
-          <a:lstStyle/>
-          <a:p>
-            <a:pPr marL="0" indent="0">
-              <a:buNone/>
-            </a:pPr>
-            <a:r>
-              <a:rPr lang="en-US" sz="1250" dirty="0">
-                <a:solidFill>
-                  <a:srgbClr val="1E2D27"/>
-                </a:solidFill>
-                <a:latin typeface="Calibri" pitchFamily="34" charset="0"/>
-                <a:ea typeface="Calibri" pitchFamily="34" charset="-122"/>
-                <a:cs typeface="Calibri" pitchFamily="34" charset="-120"/>
-              </a:rPr>
-              <a:t>Pilih model best.pt dari folder runs/rice_detection/weights/</a:t>
-            </a:r>
-            <a:endParaRPr lang="en-US" sz="1250" dirty="0"/>
-          </a:p>
-        </p:txBody>
-      </p:sp>
-      <p:sp>
-        <p:nvSpPr>
-          <p:cNvPr id="19" name="Shape 17"/>
-          <p:cNvSpPr/>
-          <p:nvPr/>
-        </p:nvSpPr>
-        <p:spPr>
-          <a:xfrm>
-            <a:off x="4800600" y="1078992"/>
-            <a:ext cx="4069080" cy="1143000"/>
-          </a:xfrm>
-          <a:prstGeom prst="roundRect">
-            <a:avLst>
-              <a:gd name="adj" fmla="val 8000"/>
-            </a:avLst>
-          </a:prstGeom>
-          <a:solidFill>
-            <a:srgbClr val="F4FAF7"/>
-          </a:solidFill>
-          <a:ln w="6350">
-            <a:solidFill>
-              <a:srgbClr val="D0E8DC"/>
-            </a:solidFill>
-            <a:prstDash val="solid"/>
-          </a:ln>
-          <a:effectLst>
-            <a:outerShdw blurRad="101600" dist="38100" dir="2700000" algn="bl" rotWithShape="0">
-              <a:srgbClr val="000000">
-                <a:alpha val="12000"/>
-              </a:srgbClr>
-            </a:outerShdw>
-          </a:effectLst>
-        </p:spPr>
-      </p:sp>
-      <p:sp>
-        <p:nvSpPr>
-          <p:cNvPr id="20" name="Shape 18"/>
-          <p:cNvSpPr/>
-          <p:nvPr/>
-        </p:nvSpPr>
-        <p:spPr>
-          <a:xfrm>
-            <a:off x="4937760" y="1371600"/>
-            <a:ext cx="548640" cy="548640"/>
-          </a:xfrm>
-          <a:prstGeom prst="ellipse">
-            <a:avLst/>
-          </a:prstGeom>
-          <a:solidFill>
-            <a:srgbClr val="1A6B4A"/>
-          </a:solidFill>
-          <a:ln w="12700">
-            <a:solidFill>
-              <a:srgbClr val="1A6B4A"/>
-            </a:solidFill>
-            <a:prstDash val="solid"/>
-          </a:ln>
-        </p:spPr>
-      </p:sp>
-      <p:sp>
-        <p:nvSpPr>
-          <p:cNvPr id="21" name="Text 19"/>
-          <p:cNvSpPr/>
-          <p:nvPr/>
-        </p:nvSpPr>
-        <p:spPr>
-          <a:xfrm>
-            <a:off x="4937760" y="1371600"/>
-            <a:ext cx="548640" cy="548640"/>
-          </a:xfrm>
-          <a:prstGeom prst="rect">
-            <a:avLst/>
-          </a:prstGeom>
-          <a:noFill/>
-          <a:ln/>
-        </p:spPr>
-        <p:txBody>
-          <a:bodyPr wrap="square" lIns="0" tIns="0" rIns="0" bIns="0" rtlCol="0" anchor="ctr"/>
-          <a:lstStyle/>
-          <a:p>
-            <a:pPr marL="0" indent="0" algn="ctr">
-              <a:buNone/>
-            </a:pPr>
-            <a:r>
-              <a:rPr lang="en-US" sz="1400" b="1" dirty="0">
-                <a:solidFill>
-                  <a:srgbClr val="FFFFFF"/>
-                </a:solidFill>
-              </a:rPr>
-              <a:t>4</a:t>
-            </a:r>
-            <a:endParaRPr lang="en-US" sz="1400" dirty="0"/>
-          </a:p>
-        </p:txBody>
-      </p:sp>
-      <p:sp>
-        <p:nvSpPr>
-          <p:cNvPr id="22" name="Text 20"/>
-          <p:cNvSpPr/>
-          <p:nvPr/>
-        </p:nvSpPr>
-        <p:spPr>
-          <a:xfrm>
-            <a:off x="5605272" y="1124712"/>
-            <a:ext cx="3127248" cy="1051560"/>
-          </a:xfrm>
-          <a:prstGeom prst="rect">
-            <a:avLst/>
-          </a:prstGeom>
-          <a:noFill/>
-          <a:ln/>
-        </p:spPr>
-        <p:txBody>
-          <a:bodyPr wrap="square" rtlCol="0" anchor="ctr"/>
-          <a:lstStyle/>
-          <a:p>
-            <a:pPr marL="0" indent="0">
-              <a:buNone/>
-            </a:pPr>
-            <a:r>
-              <a:rPr lang="en-US" sz="1250" dirty="0">
-                <a:solidFill>
-                  <a:srgbClr val="1E2D27"/>
-                </a:solidFill>
-                <a:latin typeface="Calibri" pitchFamily="34" charset="0"/>
-                <a:ea typeface="Calibri" pitchFamily="34" charset="-122"/>
-                <a:cs typeface="Calibri" pitchFamily="34" charset="-120"/>
-              </a:rPr>
-              <a:t>Pilih gambar dari folder dataset/</a:t>
-            </a:r>
-            <a:endParaRPr lang="en-US" sz="1250" dirty="0"/>
-          </a:p>
-        </p:txBody>
-      </p:sp>
-      <p:sp>
-        <p:nvSpPr>
-          <p:cNvPr id="23" name="Shape 21"/>
-          <p:cNvSpPr/>
-          <p:nvPr/>
-        </p:nvSpPr>
-        <p:spPr>
-          <a:xfrm>
-            <a:off x="4800600" y="2377440"/>
-            <a:ext cx="4069080" cy="1143000"/>
-          </a:xfrm>
-          <a:prstGeom prst="roundRect">
-            <a:avLst>
-              <a:gd name="adj" fmla="val 8000"/>
-            </a:avLst>
-          </a:prstGeom>
-          <a:solidFill>
-            <a:srgbClr val="F4FAF7"/>
-          </a:solidFill>
-          <a:ln w="6350">
-            <a:solidFill>
-              <a:srgbClr val="D0E8DC"/>
-            </a:solidFill>
-            <a:prstDash val="solid"/>
-          </a:ln>
-          <a:effectLst>
-            <a:outerShdw blurRad="101600" dist="38100" dir="2700000" algn="bl" rotWithShape="0">
-              <a:srgbClr val="000000">
-                <a:alpha val="12000"/>
-              </a:srgbClr>
-            </a:outerShdw>
-          </a:effectLst>
-        </p:spPr>
-      </p:sp>
-      <p:sp>
-        <p:nvSpPr>
-          <p:cNvPr id="24" name="Shape 22"/>
-          <p:cNvSpPr/>
-          <p:nvPr/>
-        </p:nvSpPr>
-        <p:spPr>
-          <a:xfrm>
-            <a:off x="4937760" y="2670048"/>
-            <a:ext cx="548640" cy="548640"/>
-          </a:xfrm>
-          <a:prstGeom prst="ellipse">
-            <a:avLst/>
-          </a:prstGeom>
-          <a:solidFill>
-            <a:srgbClr val="1A6B4A"/>
-          </a:solidFill>
-          <a:ln w="12700">
-            <a:solidFill>
-              <a:srgbClr val="1A6B4A"/>
-            </a:solidFill>
-            <a:prstDash val="solid"/>
-          </a:ln>
-        </p:spPr>
-      </p:sp>
-      <p:sp>
-        <p:nvSpPr>
-          <p:cNvPr id="25" name="Text 23"/>
-          <p:cNvSpPr/>
-          <p:nvPr/>
-        </p:nvSpPr>
-        <p:spPr>
-          <a:xfrm>
-            <a:off x="4937760" y="2670048"/>
-            <a:ext cx="548640" cy="548640"/>
-          </a:xfrm>
-          <a:prstGeom prst="rect">
-            <a:avLst/>
-          </a:prstGeom>
-          <a:noFill/>
-          <a:ln/>
-        </p:spPr>
-        <p:txBody>
-          <a:bodyPr wrap="square" lIns="0" tIns="0" rIns="0" bIns="0" rtlCol="0" anchor="ctr"/>
-          <a:lstStyle/>
-          <a:p>
-            <a:pPr marL="0" indent="0" algn="ctr">
-              <a:buNone/>
-            </a:pPr>
-            <a:r>
-              <a:rPr lang="en-US" sz="1400" b="1" dirty="0">
-                <a:solidFill>
-                  <a:srgbClr val="FFFFFF"/>
-                </a:solidFill>
-              </a:rPr>
-              <a:t>5</a:t>
-            </a:r>
-            <a:endParaRPr lang="en-US" sz="1400" dirty="0"/>
-          </a:p>
-        </p:txBody>
-      </p:sp>
-      <p:sp>
-        <p:nvSpPr>
-          <p:cNvPr id="26" name="Text 24"/>
-          <p:cNvSpPr/>
-          <p:nvPr/>
-        </p:nvSpPr>
-        <p:spPr>
-          <a:xfrm>
-            <a:off x="5605272" y="2423160"/>
-            <a:ext cx="3127248" cy="1051560"/>
-          </a:xfrm>
-          <a:prstGeom prst="rect">
-            <a:avLst/>
-          </a:prstGeom>
-          <a:noFill/>
-          <a:ln/>
-        </p:spPr>
-        <p:txBody>
-          <a:bodyPr wrap="square" rtlCol="0" anchor="ctr"/>
-          <a:lstStyle/>
-          <a:p>
-            <a:pPr marL="0" indent="0">
-              <a:buNone/>
-            </a:pPr>
-            <a:r>
-              <a:rPr lang="en-US" sz="1250" dirty="0">
-                <a:solidFill>
-                  <a:srgbClr val="1E2D27"/>
-                </a:solidFill>
-                <a:latin typeface="Calibri" pitchFamily="34" charset="0"/>
-                <a:ea typeface="Calibri" pitchFamily="34" charset="-122"/>
-                <a:cs typeface="Calibri" pitchFamily="34" charset="-120"/>
-              </a:rPr>
-              <a:t>Klik Prediksi — lihat jenis beras, confidence, dan bounding box</a:t>
-            </a:r>
-            <a:endParaRPr lang="en-US" sz="1250" dirty="0"/>
-          </a:p>
-        </p:txBody>
-      </p:sp>
-      <p:sp>
-        <p:nvSpPr>
-          <p:cNvPr id="27" name="Shape 25"/>
-          <p:cNvSpPr/>
-          <p:nvPr/>
-        </p:nvSpPr>
-        <p:spPr>
-          <a:xfrm>
-            <a:off x="4800600" y="3675888"/>
-            <a:ext cx="4069080" cy="1143000"/>
-          </a:xfrm>
-          <a:prstGeom prst="roundRect">
-            <a:avLst>
-              <a:gd name="adj" fmla="val 8000"/>
-            </a:avLst>
-          </a:prstGeom>
-          <a:solidFill>
-            <a:srgbClr val="F4FAF7"/>
-          </a:solidFill>
-          <a:ln w="6350">
-            <a:solidFill>
-              <a:srgbClr val="D0E8DC"/>
-            </a:solidFill>
-            <a:prstDash val="solid"/>
-          </a:ln>
-          <a:effectLst>
-            <a:outerShdw blurRad="101600" dist="38100" dir="2700000" algn="bl" rotWithShape="0">
-              <a:srgbClr val="000000">
-                <a:alpha val="12000"/>
-              </a:srgbClr>
-            </a:outerShdw>
-          </a:effectLst>
-        </p:spPr>
-      </p:sp>
-      <p:sp>
-        <p:nvSpPr>
-          <p:cNvPr id="28" name="Shape 26"/>
-          <p:cNvSpPr/>
-          <p:nvPr/>
-        </p:nvSpPr>
-        <p:spPr>
-          <a:xfrm>
-            <a:off x="4937760" y="3968496"/>
-            <a:ext cx="548640" cy="548640"/>
-          </a:xfrm>
-          <a:prstGeom prst="ellipse">
-            <a:avLst/>
-          </a:prstGeom>
-          <a:solidFill>
-            <a:srgbClr val="1A6B4A"/>
-          </a:solidFill>
-          <a:ln w="12700">
-            <a:solidFill>
-              <a:srgbClr val="1A6B4A"/>
-            </a:solidFill>
-            <a:prstDash val="solid"/>
-          </a:ln>
-        </p:spPr>
-      </p:sp>
-      <p:sp>
-        <p:nvSpPr>
-          <p:cNvPr id="29" name="Text 27"/>
-          <p:cNvSpPr/>
-          <p:nvPr/>
-        </p:nvSpPr>
-        <p:spPr>
-          <a:xfrm>
-            <a:off x="4937760" y="3968496"/>
-            <a:ext cx="548640" cy="548640"/>
-          </a:xfrm>
-          <a:prstGeom prst="rect">
-            <a:avLst/>
-          </a:prstGeom>
-          <a:noFill/>
-          <a:ln/>
-        </p:spPr>
-        <p:txBody>
-          <a:bodyPr wrap="square" lIns="0" tIns="0" rIns="0" bIns="0" rtlCol="0" anchor="ctr"/>
-          <a:lstStyle/>
-          <a:p>
-            <a:pPr marL="0" indent="0" algn="ctr">
-              <a:buNone/>
-            </a:pPr>
-            <a:r>
-              <a:rPr lang="en-US" sz="1400" b="1" dirty="0">
-                <a:solidFill>
-                  <a:srgbClr val="FFFFFF"/>
-                </a:solidFill>
-              </a:rPr>
-              <a:t>6</a:t>
-            </a:r>
-            <a:endParaRPr lang="en-US" sz="1400" dirty="0"/>
-          </a:p>
-        </p:txBody>
-      </p:sp>
-      <p:sp>
-        <p:nvSpPr>
-          <p:cNvPr id="30" name="Text 28"/>
-          <p:cNvSpPr/>
-          <p:nvPr/>
-        </p:nvSpPr>
-        <p:spPr>
-          <a:xfrm>
-            <a:off x="5605272" y="3721608"/>
-            <a:ext cx="3127248" cy="1051560"/>
-          </a:xfrm>
-          <a:prstGeom prst="rect">
-            <a:avLst/>
-          </a:prstGeom>
-          <a:noFill/>
-          <a:ln/>
-        </p:spPr>
-        <p:txBody>
-          <a:bodyPr wrap="square" rtlCol="0" anchor="ctr"/>
-          <a:lstStyle/>
-          <a:p>
-            <a:pPr marL="0" indent="0">
-              <a:buNone/>
-            </a:pPr>
-            <a:r>
-              <a:rPr lang="en-US" sz="1250" dirty="0">
-                <a:solidFill>
-                  <a:srgbClr val="1E2D27"/>
-                </a:solidFill>
-                <a:latin typeface="Calibri" pitchFamily="34" charset="0"/>
-                <a:ea typeface="Calibri" pitchFamily="34" charset="-122"/>
-                <a:cs typeface="Calibri" pitchFamily="34" charset="-120"/>
-              </a:rPr>
-              <a:t>Klik Simpan Hasil — file tersimpan di hasil_prediksi/nama_kelas/</a:t>
-            </a:r>
-            <a:endParaRPr lang="en-US" sz="1250" dirty="0"/>
+              <a:t>TERIMA KASIH</a:t>
+            </a:r>
+            <a:endParaRPr lang="en-US" sz="6600" dirty="0"/>
           </a:p>
         </p:txBody>
       </p:sp>
@@ -8188,7 +5278,7 @@
                 <a:ea typeface="Cambria" pitchFamily="34" charset="-122"/>
                 <a:cs typeface="Cambria" pitchFamily="34" charset="-120"/>
               </a:rPr>
-              <a:t>Tujuan Project</a:t>
+              <a:t>Alur Project</a:t>
             </a:r>
             <a:endParaRPr lang="en-US" sz="2200" dirty="0"/>
           </a:p>
@@ -8959,7 +6049,7 @@
         </p:nvSpPr>
         <p:spPr>
           <a:xfrm>
-            <a:off x="320040" y="137160"/>
+            <a:off x="320040" y="222885"/>
             <a:ext cx="457200" cy="457200"/>
           </a:xfrm>
           <a:prstGeom prst="roundRect">
@@ -8986,7 +6076,7 @@
         </p:nvSpPr>
         <p:spPr>
           <a:xfrm>
-            <a:off x="320040" y="137160"/>
+            <a:off x="320040" y="222885"/>
             <a:ext cx="457200" cy="457200"/>
           </a:xfrm>
           <a:prstGeom prst="rect">
@@ -9246,16 +6336,10 @@
                 <a:ea typeface="Courier New" pitchFamily="34" charset="-122"/>
                 <a:cs typeface="Courier New" pitchFamily="34" charset="-120"/>
               </a:rPr>
-              <a:t>  yolo_rice_dataset/</a:t>
-            </a:r>
-            <a:endParaRPr lang="en-US" sz="1250" dirty="0"/>
-          </a:p>
-          <a:p>
-            <a:pPr marL="0" indent="0">
-              <a:buNone/>
-            </a:pPr>
-            <a:r>
-              <a:rPr lang="en-US" sz="1250" dirty="0">
+              <a:t>  </a:t>
+            </a:r>
+            <a:r>
+              <a:rPr lang="en-US" sz="1250" dirty="0" err="1">
                 <a:solidFill>
                   <a:srgbClr val="7EFFD3"/>
                 </a:solidFill>
@@ -9263,14 +6347,8 @@
                 <a:ea typeface="Courier New" pitchFamily="34" charset="-122"/>
                 <a:cs typeface="Courier New" pitchFamily="34" charset="-120"/>
               </a:rPr>
-              <a:t>  runs/</a:t>
-            </a:r>
-            <a:endParaRPr lang="en-US" sz="1250" dirty="0"/>
-          </a:p>
-          <a:p>
-            <a:pPr marL="0" indent="0">
-              <a:buNone/>
-            </a:pPr>
+              <a:t>hasil_prediksi</a:t>
+            </a:r>
             <a:r>
               <a:rPr lang="en-US" sz="1250" dirty="0">
                 <a:solidFill>
@@ -9280,9 +6358,8 @@
                 <a:ea typeface="Courier New" pitchFamily="34" charset="-122"/>
                 <a:cs typeface="Courier New" pitchFamily="34" charset="-120"/>
               </a:rPr>
-              <a:t>  hasil_prediksi/</a:t>
-            </a:r>
-            <a:endParaRPr lang="en-US" sz="1250" dirty="0"/>
+              <a:t>/</a:t>
+            </a:r>
           </a:p>
           <a:p>
             <a:pPr marL="0" indent="0">
@@ -9297,14 +6374,10 @@
                 <a:ea typeface="Courier New" pitchFamily="34" charset="-122"/>
                 <a:cs typeface="Courier New" pitchFamily="34" charset="-120"/>
               </a:rPr>
-              <a:t>  run.py</a:t>
-            </a:r>
-            <a:endParaRPr lang="en-US" sz="1250" dirty="0"/>
-          </a:p>
-          <a:p>
-            <a:pPr marL="0" indent="0">
-              <a:buNone/>
-            </a:pPr>
+              <a:t>  runs/</a:t>
+            </a:r>
+          </a:p>
+          <a:p>
             <a:r>
               <a:rPr lang="en-US" sz="1250" dirty="0">
                 <a:solidFill>
@@ -9314,16 +6387,10 @@
                 <a:ea typeface="Courier New" pitchFamily="34" charset="-122"/>
                 <a:cs typeface="Courier New" pitchFamily="34" charset="-120"/>
               </a:rPr>
-              <a:t>  gui_predict.py</a:t>
-            </a:r>
-            <a:endParaRPr lang="en-US" sz="1250" dirty="0"/>
-          </a:p>
-          <a:p>
-            <a:pPr marL="0" indent="0">
-              <a:buNone/>
-            </a:pPr>
-            <a:r>
-              <a:rPr lang="en-US" sz="1250" dirty="0">
+              <a:t>  </a:t>
+            </a:r>
+            <a:r>
+              <a:rPr lang="en-US" sz="1250" dirty="0" err="1">
                 <a:solidFill>
                   <a:srgbClr val="7EFFD3"/>
                 </a:solidFill>
@@ -9331,14 +6398,8 @@
                 <a:ea typeface="Courier New" pitchFamily="34" charset="-122"/>
                 <a:cs typeface="Courier New" pitchFamily="34" charset="-120"/>
               </a:rPr>
-              <a:t>  requirements.txt</a:t>
-            </a:r>
-            <a:endParaRPr lang="en-US" sz="1250" dirty="0"/>
-          </a:p>
-          <a:p>
-            <a:pPr marL="0" indent="0">
-              <a:buNone/>
-            </a:pPr>
+              <a:t>yolo_rice_dataset</a:t>
+            </a:r>
             <a:r>
               <a:rPr lang="en-US" sz="1250" dirty="0">
                 <a:solidFill>
@@ -9348,7 +6409,99 @@
                 <a:ea typeface="Courier New" pitchFamily="34" charset="-122"/>
                 <a:cs typeface="Courier New" pitchFamily="34" charset="-120"/>
               </a:rPr>
-              <a:t>  laporan_akhir.md</a:t>
+              <a:t>/</a:t>
+            </a:r>
+          </a:p>
+          <a:p>
+            <a:r>
+              <a:rPr lang="en-US" sz="1250" dirty="0">
+                <a:solidFill>
+                  <a:srgbClr val="7EFFD3"/>
+                </a:solidFill>
+                <a:latin typeface="Courier New" pitchFamily="34" charset="0"/>
+                <a:cs typeface="Courier New" pitchFamily="34" charset="-120"/>
+              </a:rPr>
+              <a:t>  app_browser.py</a:t>
+            </a:r>
+            <a:endParaRPr lang="en-US" sz="1250" dirty="0"/>
+          </a:p>
+          <a:p>
+            <a:pPr marL="0" indent="0">
+              <a:buNone/>
+            </a:pPr>
+            <a:r>
+              <a:rPr lang="en-US" sz="1250" dirty="0">
+                <a:solidFill>
+                  <a:srgbClr val="7EFFD3"/>
+                </a:solidFill>
+                <a:latin typeface="Courier New" pitchFamily="34" charset="0"/>
+                <a:ea typeface="Courier New" pitchFamily="34" charset="-122"/>
+                <a:cs typeface="Courier New" pitchFamily="34" charset="-120"/>
+              </a:rPr>
+              <a:t>  requirements.txt</a:t>
+            </a:r>
+          </a:p>
+          <a:p>
+            <a:pPr marL="0" indent="0">
+              <a:buNone/>
+            </a:pPr>
+            <a:r>
+              <a:rPr lang="en-US" sz="1250" dirty="0">
+                <a:solidFill>
+                  <a:srgbClr val="7EFFD3"/>
+                </a:solidFill>
+                <a:latin typeface="Courier New" pitchFamily="34" charset="0"/>
+                <a:ea typeface="Courier New" pitchFamily="34" charset="-122"/>
+                <a:cs typeface="Courier New" pitchFamily="34" charset="-120"/>
+              </a:rPr>
+              <a:t>  rename_manifest.csv</a:t>
+            </a:r>
+          </a:p>
+          <a:p>
+            <a:r>
+              <a:rPr lang="en-US" sz="1250" dirty="0">
+                <a:solidFill>
+                  <a:srgbClr val="7EFFD3"/>
+                </a:solidFill>
+                <a:latin typeface="Courier New" pitchFamily="34" charset="0"/>
+                <a:cs typeface="Courier New" pitchFamily="34" charset="-120"/>
+              </a:rPr>
+              <a:t>  </a:t>
+            </a:r>
+            <a:r>
+              <a:rPr lang="en-US" sz="1250" dirty="0">
+                <a:solidFill>
+                  <a:srgbClr val="7EFFD3"/>
+                </a:solidFill>
+                <a:latin typeface="Courier New" pitchFamily="34" charset="0"/>
+                <a:ea typeface="Courier New" pitchFamily="34" charset="-122"/>
+                <a:cs typeface="Courier New" pitchFamily="34" charset="-120"/>
+              </a:rPr>
+              <a:t>run.py</a:t>
+            </a:r>
+          </a:p>
+          <a:p>
+            <a:r>
+              <a:rPr lang="en-US" sz="1250" dirty="0">
+                <a:solidFill>
+                  <a:srgbClr val="7EFFD3"/>
+                </a:solidFill>
+                <a:latin typeface="Courier New" pitchFamily="34" charset="0"/>
+                <a:cs typeface="Courier New" pitchFamily="34" charset="-120"/>
+              </a:rPr>
+              <a:t>  yolo26n.pt</a:t>
+            </a:r>
+          </a:p>
+          <a:p>
+            <a:r>
+              <a:rPr lang="en-US" sz="1250" dirty="0">
+                <a:solidFill>
+                  <a:srgbClr val="7EFFD3"/>
+                </a:solidFill>
+                <a:latin typeface="Courier New" pitchFamily="34" charset="0"/>
+                <a:cs typeface="Courier New" pitchFamily="34" charset="-120"/>
+              </a:rPr>
+              <a:t>  yolov8n.pt</a:t>
             </a:r>
             <a:endParaRPr lang="en-US" sz="1250" dirty="0"/>
           </a:p>
@@ -9460,7 +6613,29 @@
                 <a:ea typeface="Calibri" pitchFamily="34" charset="-122"/>
                 <a:cs typeface="Calibri" pitchFamily="34" charset="-120"/>
               </a:rPr>
-              <a:t>Gambar asli per kelas beras</a:t>
+              <a:t>Gambar </a:t>
+            </a:r>
+            <a:r>
+              <a:rPr lang="en-US" sz="1200" dirty="0" err="1">
+                <a:solidFill>
+                  <a:srgbClr val="5A7A6E"/>
+                </a:solidFill>
+                <a:latin typeface="Calibri" pitchFamily="34" charset="0"/>
+                <a:ea typeface="Calibri" pitchFamily="34" charset="-122"/>
+                <a:cs typeface="Calibri" pitchFamily="34" charset="-120"/>
+              </a:rPr>
+              <a:t>beras</a:t>
+            </a:r>
+            <a:r>
+              <a:rPr lang="en-US" sz="1200" dirty="0">
+                <a:solidFill>
+                  <a:srgbClr val="5A7A6E"/>
+                </a:solidFill>
+                <a:latin typeface="Calibri" pitchFamily="34" charset="0"/>
+                <a:ea typeface="Calibri" pitchFamily="34" charset="-122"/>
+                <a:cs typeface="Calibri" pitchFamily="34" charset="-120"/>
+              </a:rPr>
+              <a:t> per kelas beras</a:t>
             </a:r>
             <a:endParaRPr lang="en-US" sz="1200" dirty="0"/>
           </a:p>
@@ -9868,7 +7043,7 @@
         </p:nvSpPr>
         <p:spPr>
           <a:xfrm>
-            <a:off x="320040" y="137160"/>
+            <a:off x="320040" y="232410"/>
             <a:ext cx="457200" cy="457200"/>
           </a:xfrm>
           <a:prstGeom prst="roundRect">
@@ -9895,7 +7070,7 @@
         </p:nvSpPr>
         <p:spPr>
           <a:xfrm>
-            <a:off x="320040" y="137160"/>
+            <a:off x="320040" y="232410"/>
             <a:ext cx="457200" cy="457200"/>
           </a:xfrm>
           <a:prstGeom prst="rect">
@@ -11298,7 +8473,7 @@
         </p:nvSpPr>
         <p:spPr>
           <a:xfrm>
-            <a:off x="320040" y="137160"/>
+            <a:off x="320040" y="241935"/>
             <a:ext cx="457200" cy="457200"/>
           </a:xfrm>
           <a:prstGeom prst="roundRect">
@@ -11325,7 +8500,7 @@
         </p:nvSpPr>
         <p:spPr>
           <a:xfrm>
-            <a:off x="320040" y="137160"/>
+            <a:off x="320040" y="241935"/>
             <a:ext cx="457200" cy="457200"/>
           </a:xfrm>
           <a:prstGeom prst="rect">
@@ -11891,7 +9066,7 @@
         </p:nvSpPr>
         <p:spPr>
           <a:xfrm>
-            <a:off x="320040" y="137160"/>
+            <a:off x="320040" y="232410"/>
             <a:ext cx="457200" cy="457200"/>
           </a:xfrm>
           <a:prstGeom prst="roundRect">
@@ -11918,7 +9093,7 @@
         </p:nvSpPr>
         <p:spPr>
           <a:xfrm>
-            <a:off x="320040" y="137160"/>
+            <a:off x="320040" y="232410"/>
             <a:ext cx="457200" cy="457200"/>
           </a:xfrm>
           <a:prstGeom prst="rect">
@@ -12649,7 +9824,7 @@
         </p:nvSpPr>
         <p:spPr>
           <a:xfrm>
-            <a:off x="320040" y="137160"/>
+            <a:off x="320040" y="222885"/>
             <a:ext cx="457200" cy="457200"/>
           </a:xfrm>
           <a:prstGeom prst="roundRect">
@@ -12676,7 +9851,7 @@
         </p:nvSpPr>
         <p:spPr>
           <a:xfrm>
-            <a:off x="320040" y="137160"/>
+            <a:off x="320040" y="222885"/>
             <a:ext cx="457200" cy="457200"/>
           </a:xfrm>
           <a:prstGeom prst="rect">
@@ -13768,7 +10943,7 @@
         </p:nvSpPr>
         <p:spPr>
           <a:xfrm>
-            <a:off x="320040" y="137160"/>
+            <a:off x="320040" y="232410"/>
             <a:ext cx="457200" cy="457200"/>
           </a:xfrm>
           <a:prstGeom prst="roundRect">
@@ -13795,7 +10970,7 @@
         </p:nvSpPr>
         <p:spPr>
           <a:xfrm>
-            <a:off x="320040" y="137160"/>
+            <a:off x="320040" y="232410"/>
             <a:ext cx="457200" cy="457200"/>
           </a:xfrm>
           <a:prstGeom prst="rect">
@@ -14593,7 +11768,51 @@
                 <a:ea typeface="Calibri" pitchFamily="34" charset="-122"/>
                 <a:cs typeface="Calibri" pitchFamily="34" charset="-120"/>
               </a:rPr>
-              <a:t>💡  YOLOv8n adalah varian nano (paling ringan) dari YOLOv8, ideal untuk training cepat dan efisien.</a:t>
+              <a:t>💡  YOLOv8n adalah varian nano (paling ringan) </a:t>
+            </a:r>
+            <a:r>
+              <a:rPr lang="en-US" sz="1300" dirty="0" err="1">
+                <a:solidFill>
+                  <a:srgbClr val="1E2D27"/>
+                </a:solidFill>
+                <a:latin typeface="Calibri" pitchFamily="34" charset="0"/>
+                <a:ea typeface="Calibri" pitchFamily="34" charset="-122"/>
+                <a:cs typeface="Calibri" pitchFamily="34" charset="-120"/>
+              </a:rPr>
+              <a:t>dari</a:t>
+            </a:r>
+            <a:r>
+              <a:rPr lang="en-US" sz="1300" dirty="0">
+                <a:solidFill>
+                  <a:srgbClr val="1E2D27"/>
+                </a:solidFill>
+                <a:latin typeface="Calibri" pitchFamily="34" charset="0"/>
+                <a:ea typeface="Calibri" pitchFamily="34" charset="-122"/>
+                <a:cs typeface="Calibri" pitchFamily="34" charset="-120"/>
+              </a:rPr>
+              <a:t> YOLOv8 </a:t>
+            </a:r>
+            <a:r>
+              <a:rPr lang="en-US" sz="1300" dirty="0" err="1">
+                <a:solidFill>
+                  <a:srgbClr val="1E2D27"/>
+                </a:solidFill>
+                <a:latin typeface="Calibri" pitchFamily="34" charset="0"/>
+                <a:ea typeface="Calibri" pitchFamily="34" charset="-122"/>
+                <a:cs typeface="Calibri" pitchFamily="34" charset="-120"/>
+              </a:rPr>
+              <a:t>karena</a:t>
+            </a:r>
+            <a:r>
+              <a:rPr lang="en-US" sz="1300" dirty="0">
+                <a:solidFill>
+                  <a:srgbClr val="1E2D27"/>
+                </a:solidFill>
+                <a:latin typeface="Calibri" pitchFamily="34" charset="0"/>
+                <a:ea typeface="Calibri" pitchFamily="34" charset="-122"/>
+                <a:cs typeface="Calibri" pitchFamily="34" charset="-120"/>
+              </a:rPr>
+              <a:t> ideal untuk training cepat dan efisien.</a:t>
             </a:r>
             <a:endParaRPr lang="en-US" sz="1300" dirty="0"/>
           </a:p>

</xml_diff>